<commit_message>
2026/03/17 : - update chap 14 : visibility - update chap 15 : mise à jour du marché
</commit_message>
<xml_diff>
--- a/syllabus/14_mise_en_forme_CSS/syllabus_14_CSS.pptx
+++ b/syllabus/14_mise_en_forme_CSS/syllabus_14_CSS.pptx
@@ -62,9 +62,9 @@
     <p:sldId id="388" r:id="rId53"/>
     <p:sldId id="393" r:id="rId54"/>
     <p:sldId id="394" r:id="rId55"/>
-    <p:sldId id="395" r:id="rId56"/>
-    <p:sldId id="389" r:id="rId57"/>
-    <p:sldId id="390" r:id="rId58"/>
+    <p:sldId id="418" r:id="rId56"/>
+    <p:sldId id="395" r:id="rId57"/>
+    <p:sldId id="389" r:id="rId58"/>
   </p:sldIdLst>
   <p:sldSz cx="12192000" cy="6858000"/>
   <p:notesSz cx="6858000" cy="9144000"/>
@@ -242,9 +242,9 @@
             <p14:sldId id="388"/>
             <p14:sldId id="393"/>
             <p14:sldId id="394"/>
+            <p14:sldId id="418"/>
             <p14:sldId id="395"/>
             <p14:sldId id="389"/>
-            <p14:sldId id="390"/>
           </p14:sldIdLst>
         </p14:section>
       </p14:sectionLst>
@@ -278,7 +278,7 @@
       </p15:notesGuideLst>
     </p:ext>
     <p:ext uri="http://customooxmlschemas.google.com/">
-      <go:slidesCustomData xmlns="" xmlns:mc="http://schemas.openxmlformats.org/markup-compatibility/2006" xmlns:mv="urn:schemas-microsoft-com:mac:vml" xmlns:c="http://schemas.openxmlformats.org/drawingml/2006/chart" xmlns:dgm="http://schemas.openxmlformats.org/drawingml/2006/diagram" xmlns:o="urn:schemas-microsoft-com:office:office" xmlns:v="urn:schemas-microsoft-com:vml" xmlns:pvml="urn:schemas-microsoft-com:office:powerpoint" xmlns:com="http://schemas.openxmlformats.org/drawingml/2006/compatibility" xmlns:p14="http://schemas.microsoft.com/office/powerpoint/2010/main" xmlns:p15="http://schemas.microsoft.com/office/powerpoint/2012/main" xmlns:ahyp="http://schemas.microsoft.com/office/drawing/2018/hyperlinkcolor" xmlns:go="http://customooxmlschemas.google.com/" r:id="rId168" roundtripDataSignature="AMtx7mhLedDgW04K3VEM+zrhJBihBUPN4w=="/>
+      <go:slidesCustomData xmlns:go="http://customooxmlschemas.google.com/" xmlns:ahyp="http://schemas.microsoft.com/office/drawing/2018/hyperlinkcolor" xmlns:p15="http://schemas.microsoft.com/office/powerpoint/2012/main" xmlns:p14="http://schemas.microsoft.com/office/powerpoint/2010/main" xmlns:com="http://schemas.openxmlformats.org/drawingml/2006/compatibility" xmlns:pvml="urn:schemas-microsoft-com:office:powerpoint" xmlns:v="urn:schemas-microsoft-com:vml" xmlns:o="urn:schemas-microsoft-com:office:office" xmlns:dgm="http://schemas.openxmlformats.org/drawingml/2006/diagram" xmlns:c="http://schemas.openxmlformats.org/drawingml/2006/chart" xmlns:mv="urn:schemas-microsoft-com:mac:vml" xmlns:mc="http://schemas.openxmlformats.org/markup-compatibility/2006" xmlns="" r:id="rId168" roundtripDataSignature="AMtx7mhLedDgW04K3VEM+zrhJBihBUPN4w=="/>
     </p:ext>
   </p:extLst>
 </p:presentation>
@@ -7518,170 +7518,6 @@
 </p:notes>
 </file>
 
-<file path=ppt/notesSlides/notesSlide53.xml><?xml version="1.0" encoding="utf-8"?>
-<p:notes xmlns:a="http://schemas.openxmlformats.org/drawingml/2006/main" xmlns:r="http://schemas.openxmlformats.org/officeDocument/2006/relationships" xmlns:p="http://schemas.openxmlformats.org/presentationml/2006/main" showMasterSp="0" showMasterPhAnim="0">
-  <p:cSld>
-    <p:spTree>
-      <p:nvGrpSpPr>
-        <p:cNvPr id="1" name="Shape 1107"/>
-        <p:cNvGrpSpPr/>
-        <p:nvPr/>
-      </p:nvGrpSpPr>
-      <p:grpSpPr>
-        <a:xfrm>
-          <a:off x="0" y="0"/>
-          <a:ext cx="0" cy="0"/>
-          <a:chOff x="0" y="0"/>
-          <a:chExt cx="0" cy="0"/>
-        </a:xfrm>
-      </p:grpSpPr>
-      <p:sp>
-        <p:nvSpPr>
-          <p:cNvPr id="1108" name="Google Shape;1108;p135:notes"/>
-          <p:cNvSpPr>
-            <a:spLocks noGrp="1" noRot="1" noChangeAspect="1"/>
-          </p:cNvSpPr>
-          <p:nvPr>
-            <p:ph type="sldImg" idx="2"/>
-          </p:nvPr>
-        </p:nvSpPr>
-        <p:spPr>
-          <a:xfrm>
-            <a:off x="685800" y="1143000"/>
-            <a:ext cx="5486400" cy="3086100"/>
-          </a:xfrm>
-          <a:custGeom>
-            <a:avLst/>
-            <a:gdLst/>
-            <a:ahLst/>
-            <a:cxnLst/>
-            <a:rect l="l" t="t" r="r" b="b"/>
-            <a:pathLst>
-              <a:path w="120000" h="120000" extrusionOk="0">
-                <a:moveTo>
-                  <a:pt x="0" y="0"/>
-                </a:moveTo>
-                <a:lnTo>
-                  <a:pt x="120000" y="0"/>
-                </a:lnTo>
-                <a:lnTo>
-                  <a:pt x="120000" y="120000"/>
-                </a:lnTo>
-                <a:lnTo>
-                  <a:pt x="0" y="120000"/>
-                </a:lnTo>
-                <a:close/>
-              </a:path>
-            </a:pathLst>
-          </a:custGeom>
-          <a:noFill/>
-          <a:ln w="12700" cap="flat" cmpd="sng">
-            <a:solidFill>
-              <a:srgbClr val="000000"/>
-            </a:solidFill>
-            <a:prstDash val="solid"/>
-            <a:round/>
-            <a:headEnd type="none" w="sm" len="sm"/>
-            <a:tailEnd type="none" w="sm" len="sm"/>
-          </a:ln>
-        </p:spPr>
-      </p:sp>
-      <p:sp>
-        <p:nvSpPr>
-          <p:cNvPr id="1109" name="Google Shape;1109;p135:notes"/>
-          <p:cNvSpPr txBox="1">
-            <a:spLocks noGrp="1"/>
-          </p:cNvSpPr>
-          <p:nvPr>
-            <p:ph type="body" idx="1"/>
-          </p:nvPr>
-        </p:nvSpPr>
-        <p:spPr>
-          <a:xfrm>
-            <a:off x="685800" y="4400550"/>
-            <a:ext cx="5486400" cy="3600450"/>
-          </a:xfrm>
-          <a:prstGeom prst="rect">
-            <a:avLst/>
-          </a:prstGeom>
-          <a:noFill/>
-          <a:ln>
-            <a:noFill/>
-          </a:ln>
-        </p:spPr>
-        <p:txBody>
-          <a:bodyPr spcFirstLastPara="1" wrap="square" lIns="91425" tIns="45700" rIns="91425" bIns="45700" anchor="t" anchorCtr="0">
-            <a:noAutofit/>
-          </a:bodyPr>
-          <a:lstStyle/>
-          <a:p>
-            <a:pPr marL="0" lvl="0" indent="0" algn="l" rtl="0">
-              <a:spcBef>
-                <a:spcPts val="0"/>
-              </a:spcBef>
-              <a:spcAft>
-                <a:spcPts val="0"/>
-              </a:spcAft>
-              <a:buNone/>
-            </a:pPr>
-            <a:endParaRPr/>
-          </a:p>
-        </p:txBody>
-      </p:sp>
-      <p:sp>
-        <p:nvSpPr>
-          <p:cNvPr id="1110" name="Google Shape;1110;p135:notes"/>
-          <p:cNvSpPr txBox="1">
-            <a:spLocks noGrp="1"/>
-          </p:cNvSpPr>
-          <p:nvPr>
-            <p:ph type="sldNum" idx="12"/>
-          </p:nvPr>
-        </p:nvSpPr>
-        <p:spPr>
-          <a:xfrm>
-            <a:off x="3884613" y="8685213"/>
-            <a:ext cx="2971800" cy="458787"/>
-          </a:xfrm>
-          <a:prstGeom prst="rect">
-            <a:avLst/>
-          </a:prstGeom>
-          <a:noFill/>
-          <a:ln>
-            <a:noFill/>
-          </a:ln>
-        </p:spPr>
-        <p:txBody>
-          <a:bodyPr spcFirstLastPara="1" wrap="square" lIns="91425" tIns="45700" rIns="91425" bIns="45700" anchor="b" anchorCtr="0">
-            <a:noAutofit/>
-          </a:bodyPr>
-          <a:lstStyle/>
-          <a:p>
-            <a:pPr marL="0" lvl="0" indent="0" algn="r" rtl="0">
-              <a:spcBef>
-                <a:spcPts val="0"/>
-              </a:spcBef>
-              <a:spcAft>
-                <a:spcPts val="0"/>
-              </a:spcAft>
-              <a:buNone/>
-            </a:pPr>
-            <a:fld id="{00000000-1234-1234-1234-123412341234}" type="slidenum">
-              <a:rPr lang="fr-BE"/>
-              <a:t>57</a:t>
-            </a:fld>
-            <a:endParaRPr/>
-          </a:p>
-        </p:txBody>
-      </p:sp>
-    </p:spTree>
-  </p:cSld>
-  <p:clrMapOvr>
-    <a:masterClrMapping/>
-  </p:clrMapOvr>
-</p:notes>
-</file>
-
 <file path=ppt/notesSlides/notesSlide6.xml><?xml version="1.0" encoding="utf-8"?>
 <p:notes xmlns:a="http://schemas.openxmlformats.org/drawingml/2006/main" xmlns:r="http://schemas.openxmlformats.org/officeDocument/2006/relationships" xmlns:p="http://schemas.openxmlformats.org/presentationml/2006/main" showMasterSp="0" showMasterPhAnim="0">
   <p:cSld>
@@ -8327,7 +8163,7 @@
           <a:p>
             <a:fld id="{F3953782-D06E-4853-BE3C-64C197273937}" type="datetimeFigureOut">
               <a:rPr lang="fr-BE" smtClean="0"/>
-              <a:t>09-09-25</a:t>
+              <a:t>17-03-26</a:t>
             </a:fld>
             <a:endParaRPr lang="fr-BE"/>
           </a:p>
@@ -8832,7 +8668,7 @@
         <p14:reveal/>
       </p:transition>
     </mc:Choice>
-    <mc:Fallback xmlns="" xmlns:mv="urn:schemas-microsoft-com:mac:vml" xmlns:c="http://schemas.openxmlformats.org/drawingml/2006/chart" xmlns:dgm="http://schemas.openxmlformats.org/drawingml/2006/diagram" xmlns:o="urn:schemas-microsoft-com:office:office" xmlns:v="urn:schemas-microsoft-com:vml" xmlns:pvml="urn:schemas-microsoft-com:office:powerpoint" xmlns:com="http://schemas.openxmlformats.org/drawingml/2006/compatibility" xmlns:p15="http://schemas.microsoft.com/office/powerpoint/2012/main" xmlns:ahyp="http://schemas.microsoft.com/office/drawing/2018/hyperlinkcolor">
+    <mc:Fallback xmlns:ahyp="http://schemas.microsoft.com/office/drawing/2018/hyperlinkcolor" xmlns:p15="http://schemas.microsoft.com/office/powerpoint/2012/main" xmlns:com="http://schemas.openxmlformats.org/drawingml/2006/compatibility" xmlns:pvml="urn:schemas-microsoft-com:office:powerpoint" xmlns:v="urn:schemas-microsoft-com:vml" xmlns:o="urn:schemas-microsoft-com:office:office" xmlns:dgm="http://schemas.openxmlformats.org/drawingml/2006/diagram" xmlns:c="http://schemas.openxmlformats.org/drawingml/2006/chart" xmlns:mv="urn:schemas-microsoft-com:mac:vml" xmlns="">
       <p:transition spd="med">
         <p:fade/>
       </p:transition>
@@ -10285,7 +10121,7 @@
           <a:p>
             <a:fld id="{F3953782-D06E-4853-BE3C-64C197273937}" type="datetimeFigureOut">
               <a:rPr lang="fr-BE" smtClean="0"/>
-              <a:t>09-09-25</a:t>
+              <a:t>17-03-26</a:t>
             </a:fld>
             <a:endParaRPr lang="fr-BE"/>
           </a:p>
@@ -10601,7 +10437,7 @@
           <a:p>
             <a:fld id="{F3953782-D06E-4853-BE3C-64C197273937}" type="datetimeFigureOut">
               <a:rPr lang="fr-BE" smtClean="0"/>
-              <a:t>09-09-25</a:t>
+              <a:t>17-03-26</a:t>
             </a:fld>
             <a:endParaRPr lang="fr-BE"/>
           </a:p>
@@ -10799,7 +10635,7 @@
           <a:p>
             <a:fld id="{F3953782-D06E-4853-BE3C-64C197273937}" type="datetimeFigureOut">
               <a:rPr lang="fr-BE" smtClean="0"/>
-              <a:t>09-09-25</a:t>
+              <a:t>17-03-26</a:t>
             </a:fld>
             <a:endParaRPr lang="fr-BE"/>
           </a:p>
@@ -11062,7 +10898,7 @@
           <a:p>
             <a:fld id="{F3953782-D06E-4853-BE3C-64C197273937}" type="datetimeFigureOut">
               <a:rPr lang="fr-BE" smtClean="0"/>
-              <a:t>09-09-25</a:t>
+              <a:t>17-03-26</a:t>
             </a:fld>
             <a:endParaRPr lang="fr-BE"/>
           </a:p>
@@ -11459,7 +11295,7 @@
           <a:p>
             <a:fld id="{F3953782-D06E-4853-BE3C-64C197273937}" type="datetimeFigureOut">
               <a:rPr lang="fr-BE" smtClean="0"/>
-              <a:t>09-09-25</a:t>
+              <a:t>17-03-26</a:t>
             </a:fld>
             <a:endParaRPr lang="fr-BE"/>
           </a:p>
@@ -11608,7 +11444,7 @@
           <a:p>
             <a:fld id="{F3953782-D06E-4853-BE3C-64C197273937}" type="datetimeFigureOut">
               <a:rPr lang="fr-BE" smtClean="0"/>
-              <a:t>09-09-25</a:t>
+              <a:t>17-03-26</a:t>
             </a:fld>
             <a:endParaRPr lang="fr-BE"/>
           </a:p>
@@ -11958,7 +11794,7 @@
           <a:p>
             <a:fld id="{F3953782-D06E-4853-BE3C-64C197273937}" type="datetimeFigureOut">
               <a:rPr lang="fr-BE" smtClean="0"/>
-              <a:t>09-09-25</a:t>
+              <a:t>17-03-26</a:t>
             </a:fld>
             <a:endParaRPr lang="fr-BE"/>
           </a:p>
@@ -12285,7 +12121,7 @@
           <a:p>
             <a:fld id="{F3953782-D06E-4853-BE3C-64C197273937}" type="datetimeFigureOut">
               <a:rPr lang="fr-BE" smtClean="0"/>
-              <a:t>09-09-25</a:t>
+              <a:t>17-03-26</a:t>
             </a:fld>
             <a:endParaRPr lang="fr-BE"/>
           </a:p>
@@ -12899,7 +12735,7 @@
         <p14:reveal/>
       </p:transition>
     </mc:Choice>
-    <mc:Fallback xmlns="" xmlns:mv="urn:schemas-microsoft-com:mac:vml" xmlns:c="http://schemas.openxmlformats.org/drawingml/2006/chart" xmlns:dgm="http://schemas.openxmlformats.org/drawingml/2006/diagram" xmlns:o="urn:schemas-microsoft-com:office:office" xmlns:v="urn:schemas-microsoft-com:vml" xmlns:pvml="urn:schemas-microsoft-com:office:powerpoint" xmlns:com="http://schemas.openxmlformats.org/drawingml/2006/compatibility" xmlns:p15="http://schemas.microsoft.com/office/powerpoint/2012/main" xmlns:ahyp="http://schemas.microsoft.com/office/drawing/2018/hyperlinkcolor">
+    <mc:Fallback xmlns:ahyp="http://schemas.microsoft.com/office/drawing/2018/hyperlinkcolor" xmlns:p15="http://schemas.microsoft.com/office/powerpoint/2012/main" xmlns:com="http://schemas.openxmlformats.org/drawingml/2006/compatibility" xmlns:pvml="urn:schemas-microsoft-com:office:powerpoint" xmlns:v="urn:schemas-microsoft-com:vml" xmlns:o="urn:schemas-microsoft-com:office:office" xmlns:dgm="http://schemas.openxmlformats.org/drawingml/2006/diagram" xmlns:c="http://schemas.openxmlformats.org/drawingml/2006/chart" xmlns:mv="urn:schemas-microsoft-com:mac:vml" xmlns="">
       <p:transition spd="med">
         <p:fade/>
       </p:transition>
@@ -13436,7 +13272,7 @@
         <p14:reveal/>
       </p:transition>
     </mc:Choice>
-    <mc:Fallback xmlns="" xmlns:mv="urn:schemas-microsoft-com:mac:vml" xmlns:c="http://schemas.openxmlformats.org/drawingml/2006/chart" xmlns:dgm="http://schemas.openxmlformats.org/drawingml/2006/diagram" xmlns:o="urn:schemas-microsoft-com:office:office" xmlns:v="urn:schemas-microsoft-com:vml" xmlns:pvml="urn:schemas-microsoft-com:office:powerpoint" xmlns:com="http://schemas.openxmlformats.org/drawingml/2006/compatibility" xmlns:p15="http://schemas.microsoft.com/office/powerpoint/2012/main" xmlns:ahyp="http://schemas.microsoft.com/office/drawing/2018/hyperlinkcolor">
+    <mc:Fallback xmlns:ahyp="http://schemas.microsoft.com/office/drawing/2018/hyperlinkcolor" xmlns:p15="http://schemas.microsoft.com/office/powerpoint/2012/main" xmlns:com="http://schemas.openxmlformats.org/drawingml/2006/compatibility" xmlns:pvml="urn:schemas-microsoft-com:office:powerpoint" xmlns:v="urn:schemas-microsoft-com:vml" xmlns:o="urn:schemas-microsoft-com:office:office" xmlns:dgm="http://schemas.openxmlformats.org/drawingml/2006/diagram" xmlns:c="http://schemas.openxmlformats.org/drawingml/2006/chart" xmlns:mv="urn:schemas-microsoft-com:mac:vml" xmlns="">
       <p:transition spd="med">
         <p:fade/>
       </p:transition>
@@ -13582,7 +13418,7 @@
         <p14:reveal/>
       </p:transition>
     </mc:Choice>
-    <mc:Fallback xmlns="" xmlns:mv="urn:schemas-microsoft-com:mac:vml" xmlns:c="http://schemas.openxmlformats.org/drawingml/2006/chart" xmlns:dgm="http://schemas.openxmlformats.org/drawingml/2006/diagram" xmlns:o="urn:schemas-microsoft-com:office:office" xmlns:v="urn:schemas-microsoft-com:vml" xmlns:pvml="urn:schemas-microsoft-com:office:powerpoint" xmlns:com="http://schemas.openxmlformats.org/drawingml/2006/compatibility" xmlns:p15="http://schemas.microsoft.com/office/powerpoint/2012/main" xmlns:ahyp="http://schemas.microsoft.com/office/drawing/2018/hyperlinkcolor">
+    <mc:Fallback xmlns:ahyp="http://schemas.microsoft.com/office/drawing/2018/hyperlinkcolor" xmlns:p15="http://schemas.microsoft.com/office/powerpoint/2012/main" xmlns:com="http://schemas.openxmlformats.org/drawingml/2006/compatibility" xmlns:pvml="urn:schemas-microsoft-com:office:powerpoint" xmlns:v="urn:schemas-microsoft-com:vml" xmlns:o="urn:schemas-microsoft-com:office:office" xmlns:dgm="http://schemas.openxmlformats.org/drawingml/2006/diagram" xmlns:c="http://schemas.openxmlformats.org/drawingml/2006/chart" xmlns:mv="urn:schemas-microsoft-com:mac:vml" xmlns="">
       <p:transition spd="med">
         <p:fade/>
       </p:transition>
@@ -13837,7 +13673,7 @@
         <p14:reveal/>
       </p:transition>
     </mc:Choice>
-    <mc:Fallback xmlns="" xmlns:mv="urn:schemas-microsoft-com:mac:vml" xmlns:c="http://schemas.openxmlformats.org/drawingml/2006/chart" xmlns:dgm="http://schemas.openxmlformats.org/drawingml/2006/diagram" xmlns:o="urn:schemas-microsoft-com:office:office" xmlns:v="urn:schemas-microsoft-com:vml" xmlns:pvml="urn:schemas-microsoft-com:office:powerpoint" xmlns:com="http://schemas.openxmlformats.org/drawingml/2006/compatibility" xmlns:p15="http://schemas.microsoft.com/office/powerpoint/2012/main" xmlns:ahyp="http://schemas.microsoft.com/office/drawing/2018/hyperlinkcolor">
+    <mc:Fallback xmlns:ahyp="http://schemas.microsoft.com/office/drawing/2018/hyperlinkcolor" xmlns:p15="http://schemas.microsoft.com/office/powerpoint/2012/main" xmlns:com="http://schemas.openxmlformats.org/drawingml/2006/compatibility" xmlns:pvml="urn:schemas-microsoft-com:office:powerpoint" xmlns:v="urn:schemas-microsoft-com:vml" xmlns:o="urn:schemas-microsoft-com:office:office" xmlns:dgm="http://schemas.openxmlformats.org/drawingml/2006/diagram" xmlns:c="http://schemas.openxmlformats.org/drawingml/2006/chart" xmlns:mv="urn:schemas-microsoft-com:mac:vml" xmlns="">
       <p:transition spd="med">
         <p:fade/>
       </p:transition>
@@ -14080,7 +13916,7 @@
         <p14:reveal/>
       </p:transition>
     </mc:Choice>
-    <mc:Fallback xmlns="" xmlns:mv="urn:schemas-microsoft-com:mac:vml" xmlns:c="http://schemas.openxmlformats.org/drawingml/2006/chart" xmlns:dgm="http://schemas.openxmlformats.org/drawingml/2006/diagram" xmlns:o="urn:schemas-microsoft-com:office:office" xmlns:v="urn:schemas-microsoft-com:vml" xmlns:pvml="urn:schemas-microsoft-com:office:powerpoint" xmlns:com="http://schemas.openxmlformats.org/drawingml/2006/compatibility" xmlns:p15="http://schemas.microsoft.com/office/powerpoint/2012/main" xmlns:ahyp="http://schemas.microsoft.com/office/drawing/2018/hyperlinkcolor">
+    <mc:Fallback xmlns:ahyp="http://schemas.microsoft.com/office/drawing/2018/hyperlinkcolor" xmlns:p15="http://schemas.microsoft.com/office/powerpoint/2012/main" xmlns:com="http://schemas.openxmlformats.org/drawingml/2006/compatibility" xmlns:pvml="urn:schemas-microsoft-com:office:powerpoint" xmlns:v="urn:schemas-microsoft-com:vml" xmlns:o="urn:schemas-microsoft-com:office:office" xmlns:dgm="http://schemas.openxmlformats.org/drawingml/2006/diagram" xmlns:c="http://schemas.openxmlformats.org/drawingml/2006/chart" xmlns:mv="urn:schemas-microsoft-com:mac:vml" xmlns="">
       <p:transition spd="med">
         <p:fade/>
       </p:transition>
@@ -14632,7 +14468,7 @@
         <p14:reveal/>
       </p:transition>
     </mc:Choice>
-    <mc:Fallback xmlns="" xmlns:mv="urn:schemas-microsoft-com:mac:vml" xmlns:c="http://schemas.openxmlformats.org/drawingml/2006/chart" xmlns:dgm="http://schemas.openxmlformats.org/drawingml/2006/diagram" xmlns:o="urn:schemas-microsoft-com:office:office" xmlns:v="urn:schemas-microsoft-com:vml" xmlns:pvml="urn:schemas-microsoft-com:office:powerpoint" xmlns:com="http://schemas.openxmlformats.org/drawingml/2006/compatibility" xmlns:p15="http://schemas.microsoft.com/office/powerpoint/2012/main" xmlns:ahyp="http://schemas.microsoft.com/office/drawing/2018/hyperlinkcolor">
+    <mc:Fallback xmlns:ahyp="http://schemas.microsoft.com/office/drawing/2018/hyperlinkcolor" xmlns:p15="http://schemas.microsoft.com/office/powerpoint/2012/main" xmlns:com="http://schemas.openxmlformats.org/drawingml/2006/compatibility" xmlns:pvml="urn:schemas-microsoft-com:office:powerpoint" xmlns:v="urn:schemas-microsoft-com:vml" xmlns:o="urn:schemas-microsoft-com:office:office" xmlns:dgm="http://schemas.openxmlformats.org/drawingml/2006/diagram" xmlns:c="http://schemas.openxmlformats.org/drawingml/2006/chart" xmlns:mv="urn:schemas-microsoft-com:mac:vml" xmlns="">
       <p:transition spd="med">
         <p:fade/>
       </p:transition>
@@ -14897,7 +14733,7 @@
         <p14:reveal/>
       </p:transition>
     </mc:Choice>
-    <mc:Fallback xmlns="" xmlns:mv="urn:schemas-microsoft-com:mac:vml" xmlns:c="http://schemas.openxmlformats.org/drawingml/2006/chart" xmlns:dgm="http://schemas.openxmlformats.org/drawingml/2006/diagram" xmlns:o="urn:schemas-microsoft-com:office:office" xmlns:v="urn:schemas-microsoft-com:vml" xmlns:pvml="urn:schemas-microsoft-com:office:powerpoint" xmlns:com="http://schemas.openxmlformats.org/drawingml/2006/compatibility" xmlns:p15="http://schemas.microsoft.com/office/powerpoint/2012/main" xmlns:ahyp="http://schemas.microsoft.com/office/drawing/2018/hyperlinkcolor">
+    <mc:Fallback xmlns:ahyp="http://schemas.microsoft.com/office/drawing/2018/hyperlinkcolor" xmlns:p15="http://schemas.microsoft.com/office/powerpoint/2012/main" xmlns:com="http://schemas.openxmlformats.org/drawingml/2006/compatibility" xmlns:pvml="urn:schemas-microsoft-com:office:powerpoint" xmlns:v="urn:schemas-microsoft-com:vml" xmlns:o="urn:schemas-microsoft-com:office:office" xmlns:dgm="http://schemas.openxmlformats.org/drawingml/2006/diagram" xmlns:c="http://schemas.openxmlformats.org/drawingml/2006/chart" xmlns:mv="urn:schemas-microsoft-com:mac:vml" xmlns="">
       <p:transition spd="med">
         <p:fade/>
       </p:transition>
@@ -15043,7 +14879,7 @@
         <p14:reveal/>
       </p:transition>
     </mc:Choice>
-    <mc:Fallback xmlns="" xmlns:mv="urn:schemas-microsoft-com:mac:vml" xmlns:c="http://schemas.openxmlformats.org/drawingml/2006/chart" xmlns:dgm="http://schemas.openxmlformats.org/drawingml/2006/diagram" xmlns:o="urn:schemas-microsoft-com:office:office" xmlns:v="urn:schemas-microsoft-com:vml" xmlns:pvml="urn:schemas-microsoft-com:office:powerpoint" xmlns:com="http://schemas.openxmlformats.org/drawingml/2006/compatibility" xmlns:p15="http://schemas.microsoft.com/office/powerpoint/2012/main" xmlns:ahyp="http://schemas.microsoft.com/office/drawing/2018/hyperlinkcolor">
+    <mc:Fallback xmlns:ahyp="http://schemas.microsoft.com/office/drawing/2018/hyperlinkcolor" xmlns:p15="http://schemas.microsoft.com/office/powerpoint/2012/main" xmlns:com="http://schemas.openxmlformats.org/drawingml/2006/compatibility" xmlns:pvml="urn:schemas-microsoft-com:office:powerpoint" xmlns:v="urn:schemas-microsoft-com:vml" xmlns:o="urn:schemas-microsoft-com:office:office" xmlns:dgm="http://schemas.openxmlformats.org/drawingml/2006/diagram" xmlns:c="http://schemas.openxmlformats.org/drawingml/2006/chart" xmlns:mv="urn:schemas-microsoft-com:mac:vml" xmlns="">
       <p:transition spd="med">
         <p:fade/>
       </p:transition>
@@ -15536,7 +15372,7 @@
         <p14:reveal/>
       </p:transition>
     </mc:Choice>
-    <mc:Fallback xmlns="" xmlns:mv="urn:schemas-microsoft-com:mac:vml" xmlns:c="http://schemas.openxmlformats.org/drawingml/2006/chart" xmlns:dgm="http://schemas.openxmlformats.org/drawingml/2006/diagram" xmlns:o="urn:schemas-microsoft-com:office:office" xmlns:v="urn:schemas-microsoft-com:vml" xmlns:pvml="urn:schemas-microsoft-com:office:powerpoint" xmlns:com="http://schemas.openxmlformats.org/drawingml/2006/compatibility" xmlns:p15="http://schemas.microsoft.com/office/powerpoint/2012/main" xmlns:ahyp="http://schemas.microsoft.com/office/drawing/2018/hyperlinkcolor">
+    <mc:Fallback xmlns:ahyp="http://schemas.microsoft.com/office/drawing/2018/hyperlinkcolor" xmlns:p15="http://schemas.microsoft.com/office/powerpoint/2012/main" xmlns:com="http://schemas.openxmlformats.org/drawingml/2006/compatibility" xmlns:pvml="urn:schemas-microsoft-com:office:powerpoint" xmlns:v="urn:schemas-microsoft-com:vml" xmlns:o="urn:schemas-microsoft-com:office:office" xmlns:dgm="http://schemas.openxmlformats.org/drawingml/2006/diagram" xmlns:c="http://schemas.openxmlformats.org/drawingml/2006/chart" xmlns:mv="urn:schemas-microsoft-com:mac:vml" xmlns="">
       <p:transition spd="med">
         <p:fade/>
       </p:transition>
@@ -15967,7 +15803,7 @@
         <p14:reveal/>
       </p:transition>
     </mc:Choice>
-    <mc:Fallback xmlns="" xmlns:mv="urn:schemas-microsoft-com:mac:vml" xmlns:c="http://schemas.openxmlformats.org/drawingml/2006/chart" xmlns:dgm="http://schemas.openxmlformats.org/drawingml/2006/diagram" xmlns:o="urn:schemas-microsoft-com:office:office" xmlns:v="urn:schemas-microsoft-com:vml" xmlns:pvml="urn:schemas-microsoft-com:office:powerpoint" xmlns:com="http://schemas.openxmlformats.org/drawingml/2006/compatibility" xmlns:p15="http://schemas.microsoft.com/office/powerpoint/2012/main" xmlns:ahyp="http://schemas.microsoft.com/office/drawing/2018/hyperlinkcolor">
+    <mc:Fallback xmlns:ahyp="http://schemas.microsoft.com/office/drawing/2018/hyperlinkcolor" xmlns:p15="http://schemas.microsoft.com/office/powerpoint/2012/main" xmlns:com="http://schemas.openxmlformats.org/drawingml/2006/compatibility" xmlns:pvml="urn:schemas-microsoft-com:office:powerpoint" xmlns:v="urn:schemas-microsoft-com:vml" xmlns:o="urn:schemas-microsoft-com:office:office" xmlns:dgm="http://schemas.openxmlformats.org/drawingml/2006/diagram" xmlns:c="http://schemas.openxmlformats.org/drawingml/2006/chart" xmlns:mv="urn:schemas-microsoft-com:mac:vml" xmlns="">
       <p:transition spd="med">
         <p:fade/>
       </p:transition>
@@ -16138,7 +15974,7 @@
         <p14:reveal/>
       </p:transition>
     </mc:Choice>
-    <mc:Fallback xmlns="" xmlns:mv="urn:schemas-microsoft-com:mac:vml" xmlns:c="http://schemas.openxmlformats.org/drawingml/2006/chart" xmlns:dgm="http://schemas.openxmlformats.org/drawingml/2006/diagram" xmlns:o="urn:schemas-microsoft-com:office:office" xmlns:v="urn:schemas-microsoft-com:vml" xmlns:pvml="urn:schemas-microsoft-com:office:powerpoint" xmlns:com="http://schemas.openxmlformats.org/drawingml/2006/compatibility" xmlns:p15="http://schemas.microsoft.com/office/powerpoint/2012/main" xmlns:ahyp="http://schemas.microsoft.com/office/drawing/2018/hyperlinkcolor">
+    <mc:Fallback xmlns:ahyp="http://schemas.microsoft.com/office/drawing/2018/hyperlinkcolor" xmlns:p15="http://schemas.microsoft.com/office/powerpoint/2012/main" xmlns:com="http://schemas.openxmlformats.org/drawingml/2006/compatibility" xmlns:pvml="urn:schemas-microsoft-com:office:powerpoint" xmlns:v="urn:schemas-microsoft-com:vml" xmlns:o="urn:schemas-microsoft-com:office:office" xmlns:dgm="http://schemas.openxmlformats.org/drawingml/2006/diagram" xmlns:c="http://schemas.openxmlformats.org/drawingml/2006/chart" xmlns:mv="urn:schemas-microsoft-com:mac:vml" xmlns="">
       <p:transition spd="med">
         <p:fade/>
       </p:transition>
@@ -16538,7 +16374,7 @@
         <p14:reveal/>
       </p:transition>
     </mc:Choice>
-    <mc:Fallback xmlns:ahyp="http://schemas.microsoft.com/office/drawing/2018/hyperlinkcolor" xmlns:p15="http://schemas.microsoft.com/office/powerpoint/2012/main" xmlns:com="http://schemas.openxmlformats.org/drawingml/2006/compatibility" xmlns:pvml="urn:schemas-microsoft-com:office:powerpoint" xmlns:v="urn:schemas-microsoft-com:vml" xmlns:o="urn:schemas-microsoft-com:office:office" xmlns:dgm="http://schemas.openxmlformats.org/drawingml/2006/diagram" xmlns:c="http://schemas.openxmlformats.org/drawingml/2006/chart" xmlns:mv="urn:schemas-microsoft-com:mac:vml" xmlns="">
+    <mc:Fallback xmlns="" xmlns:mv="urn:schemas-microsoft-com:mac:vml" xmlns:c="http://schemas.openxmlformats.org/drawingml/2006/chart" xmlns:dgm="http://schemas.openxmlformats.org/drawingml/2006/diagram" xmlns:o="urn:schemas-microsoft-com:office:office" xmlns:v="urn:schemas-microsoft-com:vml" xmlns:pvml="urn:schemas-microsoft-com:office:powerpoint" xmlns:com="http://schemas.openxmlformats.org/drawingml/2006/compatibility" xmlns:p15="http://schemas.microsoft.com/office/powerpoint/2012/main" xmlns:ahyp="http://schemas.microsoft.com/office/drawing/2018/hyperlinkcolor">
       <p:transition spd="med">
         <p:fade/>
       </p:transition>
@@ -16891,7 +16727,7 @@
         <p14:reveal/>
       </p:transition>
     </mc:Choice>
-    <mc:Fallback xmlns="" xmlns:mv="urn:schemas-microsoft-com:mac:vml" xmlns:c="http://schemas.openxmlformats.org/drawingml/2006/chart" xmlns:dgm="http://schemas.openxmlformats.org/drawingml/2006/diagram" xmlns:o="urn:schemas-microsoft-com:office:office" xmlns:v="urn:schemas-microsoft-com:vml" xmlns:pvml="urn:schemas-microsoft-com:office:powerpoint" xmlns:com="http://schemas.openxmlformats.org/drawingml/2006/compatibility" xmlns:p15="http://schemas.microsoft.com/office/powerpoint/2012/main" xmlns:ahyp="http://schemas.microsoft.com/office/drawing/2018/hyperlinkcolor">
+    <mc:Fallback xmlns:ahyp="http://schemas.microsoft.com/office/drawing/2018/hyperlinkcolor" xmlns:p15="http://schemas.microsoft.com/office/powerpoint/2012/main" xmlns:com="http://schemas.openxmlformats.org/drawingml/2006/compatibility" xmlns:pvml="urn:schemas-microsoft-com:office:powerpoint" xmlns:v="urn:schemas-microsoft-com:vml" xmlns:o="urn:schemas-microsoft-com:office:office" xmlns:dgm="http://schemas.openxmlformats.org/drawingml/2006/diagram" xmlns:c="http://schemas.openxmlformats.org/drawingml/2006/chart" xmlns:mv="urn:schemas-microsoft-com:mac:vml" xmlns="">
       <p:transition spd="med">
         <p:fade/>
       </p:transition>
@@ -17213,7 +17049,7 @@
         <p14:reveal/>
       </p:transition>
     </mc:Choice>
-    <mc:Fallback xmlns="" xmlns:mv="urn:schemas-microsoft-com:mac:vml" xmlns:c="http://schemas.openxmlformats.org/drawingml/2006/chart" xmlns:dgm="http://schemas.openxmlformats.org/drawingml/2006/diagram" xmlns:o="urn:schemas-microsoft-com:office:office" xmlns:v="urn:schemas-microsoft-com:vml" xmlns:pvml="urn:schemas-microsoft-com:office:powerpoint" xmlns:com="http://schemas.openxmlformats.org/drawingml/2006/compatibility" xmlns:p15="http://schemas.microsoft.com/office/powerpoint/2012/main" xmlns:ahyp="http://schemas.microsoft.com/office/drawing/2018/hyperlinkcolor">
+    <mc:Fallback xmlns:ahyp="http://schemas.microsoft.com/office/drawing/2018/hyperlinkcolor" xmlns:p15="http://schemas.microsoft.com/office/powerpoint/2012/main" xmlns:com="http://schemas.openxmlformats.org/drawingml/2006/compatibility" xmlns:pvml="urn:schemas-microsoft-com:office:powerpoint" xmlns:v="urn:schemas-microsoft-com:vml" xmlns:o="urn:schemas-microsoft-com:office:office" xmlns:dgm="http://schemas.openxmlformats.org/drawingml/2006/diagram" xmlns:c="http://schemas.openxmlformats.org/drawingml/2006/chart" xmlns:mv="urn:schemas-microsoft-com:mac:vml" xmlns="">
       <p:transition spd="med">
         <p:fade/>
       </p:transition>
@@ -17604,7 +17440,7 @@
         <p14:reveal/>
       </p:transition>
     </mc:Choice>
-    <mc:Fallback xmlns="" xmlns:mv="urn:schemas-microsoft-com:mac:vml" xmlns:c="http://schemas.openxmlformats.org/drawingml/2006/chart" xmlns:dgm="http://schemas.openxmlformats.org/drawingml/2006/diagram" xmlns:o="urn:schemas-microsoft-com:office:office" xmlns:v="urn:schemas-microsoft-com:vml" xmlns:pvml="urn:schemas-microsoft-com:office:powerpoint" xmlns:com="http://schemas.openxmlformats.org/drawingml/2006/compatibility" xmlns:p15="http://schemas.microsoft.com/office/powerpoint/2012/main" xmlns:ahyp="http://schemas.microsoft.com/office/drawing/2018/hyperlinkcolor">
+    <mc:Fallback xmlns:ahyp="http://schemas.microsoft.com/office/drawing/2018/hyperlinkcolor" xmlns:p15="http://schemas.microsoft.com/office/powerpoint/2012/main" xmlns:com="http://schemas.openxmlformats.org/drawingml/2006/compatibility" xmlns:pvml="urn:schemas-microsoft-com:office:powerpoint" xmlns:v="urn:schemas-microsoft-com:vml" xmlns:o="urn:schemas-microsoft-com:office:office" xmlns:dgm="http://schemas.openxmlformats.org/drawingml/2006/diagram" xmlns:c="http://schemas.openxmlformats.org/drawingml/2006/chart" xmlns:mv="urn:schemas-microsoft-com:mac:vml" xmlns="">
       <p:transition spd="med">
         <p:fade/>
       </p:transition>
@@ -18073,7 +17909,7 @@
         <p14:reveal/>
       </p:transition>
     </mc:Choice>
-    <mc:Fallback xmlns="" xmlns:mv="urn:schemas-microsoft-com:mac:vml" xmlns:c="http://schemas.openxmlformats.org/drawingml/2006/chart" xmlns:dgm="http://schemas.openxmlformats.org/drawingml/2006/diagram" xmlns:o="urn:schemas-microsoft-com:office:office" xmlns:v="urn:schemas-microsoft-com:vml" xmlns:pvml="urn:schemas-microsoft-com:office:powerpoint" xmlns:com="http://schemas.openxmlformats.org/drawingml/2006/compatibility" xmlns:p15="http://schemas.microsoft.com/office/powerpoint/2012/main" xmlns:ahyp="http://schemas.microsoft.com/office/drawing/2018/hyperlinkcolor">
+    <mc:Fallback xmlns:ahyp="http://schemas.microsoft.com/office/drawing/2018/hyperlinkcolor" xmlns:p15="http://schemas.microsoft.com/office/powerpoint/2012/main" xmlns:com="http://schemas.openxmlformats.org/drawingml/2006/compatibility" xmlns:pvml="urn:schemas-microsoft-com:office:powerpoint" xmlns:v="urn:schemas-microsoft-com:vml" xmlns:o="urn:schemas-microsoft-com:office:office" xmlns:dgm="http://schemas.openxmlformats.org/drawingml/2006/diagram" xmlns:c="http://schemas.openxmlformats.org/drawingml/2006/chart" xmlns:mv="urn:schemas-microsoft-com:mac:vml" xmlns="">
       <p:transition spd="med">
         <p:fade/>
       </p:transition>
@@ -18640,7 +18476,7 @@
         <p14:reveal/>
       </p:transition>
     </mc:Choice>
-    <mc:Fallback xmlns="" xmlns:mv="urn:schemas-microsoft-com:mac:vml" xmlns:c="http://schemas.openxmlformats.org/drawingml/2006/chart" xmlns:dgm="http://schemas.openxmlformats.org/drawingml/2006/diagram" xmlns:o="urn:schemas-microsoft-com:office:office" xmlns:v="urn:schemas-microsoft-com:vml" xmlns:pvml="urn:schemas-microsoft-com:office:powerpoint" xmlns:com="http://schemas.openxmlformats.org/drawingml/2006/compatibility" xmlns:p15="http://schemas.microsoft.com/office/powerpoint/2012/main" xmlns:ahyp="http://schemas.microsoft.com/office/drawing/2018/hyperlinkcolor">
+    <mc:Fallback xmlns:ahyp="http://schemas.microsoft.com/office/drawing/2018/hyperlinkcolor" xmlns:p15="http://schemas.microsoft.com/office/powerpoint/2012/main" xmlns:com="http://schemas.openxmlformats.org/drawingml/2006/compatibility" xmlns:pvml="urn:schemas-microsoft-com:office:powerpoint" xmlns:v="urn:schemas-microsoft-com:vml" xmlns:o="urn:schemas-microsoft-com:office:office" xmlns:dgm="http://schemas.openxmlformats.org/drawingml/2006/diagram" xmlns:c="http://schemas.openxmlformats.org/drawingml/2006/chart" xmlns:mv="urn:schemas-microsoft-com:mac:vml" xmlns="">
       <p:transition spd="med">
         <p:fade/>
       </p:transition>
@@ -19050,7 +18886,7 @@
         <p14:reveal/>
       </p:transition>
     </mc:Choice>
-    <mc:Fallback xmlns="" xmlns:mv="urn:schemas-microsoft-com:mac:vml" xmlns:c="http://schemas.openxmlformats.org/drawingml/2006/chart" xmlns:dgm="http://schemas.openxmlformats.org/drawingml/2006/diagram" xmlns:o="urn:schemas-microsoft-com:office:office" xmlns:v="urn:schemas-microsoft-com:vml" xmlns:pvml="urn:schemas-microsoft-com:office:powerpoint" xmlns:com="http://schemas.openxmlformats.org/drawingml/2006/compatibility" xmlns:p15="http://schemas.microsoft.com/office/powerpoint/2012/main" xmlns:ahyp="http://schemas.microsoft.com/office/drawing/2018/hyperlinkcolor">
+    <mc:Fallback xmlns:ahyp="http://schemas.microsoft.com/office/drawing/2018/hyperlinkcolor" xmlns:p15="http://schemas.microsoft.com/office/powerpoint/2012/main" xmlns:com="http://schemas.openxmlformats.org/drawingml/2006/compatibility" xmlns:pvml="urn:schemas-microsoft-com:office:powerpoint" xmlns:v="urn:schemas-microsoft-com:vml" xmlns:o="urn:schemas-microsoft-com:office:office" xmlns:dgm="http://schemas.openxmlformats.org/drawingml/2006/diagram" xmlns:c="http://schemas.openxmlformats.org/drawingml/2006/chart" xmlns:mv="urn:schemas-microsoft-com:mac:vml" xmlns="">
       <p:transition spd="med">
         <p:fade/>
       </p:transition>
@@ -19500,7 +19336,7 @@
         <p14:reveal/>
       </p:transition>
     </mc:Choice>
-    <mc:Fallback xmlns="" xmlns:mv="urn:schemas-microsoft-com:mac:vml" xmlns:c="http://schemas.openxmlformats.org/drawingml/2006/chart" xmlns:dgm="http://schemas.openxmlformats.org/drawingml/2006/diagram" xmlns:o="urn:schemas-microsoft-com:office:office" xmlns:v="urn:schemas-microsoft-com:vml" xmlns:pvml="urn:schemas-microsoft-com:office:powerpoint" xmlns:com="http://schemas.openxmlformats.org/drawingml/2006/compatibility" xmlns:p15="http://schemas.microsoft.com/office/powerpoint/2012/main" xmlns:ahyp="http://schemas.microsoft.com/office/drawing/2018/hyperlinkcolor">
+    <mc:Fallback xmlns:ahyp="http://schemas.microsoft.com/office/drawing/2018/hyperlinkcolor" xmlns:p15="http://schemas.microsoft.com/office/powerpoint/2012/main" xmlns:com="http://schemas.openxmlformats.org/drawingml/2006/compatibility" xmlns:pvml="urn:schemas-microsoft-com:office:powerpoint" xmlns:v="urn:schemas-microsoft-com:vml" xmlns:o="urn:schemas-microsoft-com:office:office" xmlns:dgm="http://schemas.openxmlformats.org/drawingml/2006/diagram" xmlns:c="http://schemas.openxmlformats.org/drawingml/2006/chart" xmlns:mv="urn:schemas-microsoft-com:mac:vml" xmlns="">
       <p:transition spd="med">
         <p:fade/>
       </p:transition>
@@ -19865,7 +19701,7 @@
         <p14:reveal/>
       </p:transition>
     </mc:Choice>
-    <mc:Fallback xmlns="" xmlns:mv="urn:schemas-microsoft-com:mac:vml" xmlns:c="http://schemas.openxmlformats.org/drawingml/2006/chart" xmlns:dgm="http://schemas.openxmlformats.org/drawingml/2006/diagram" xmlns:o="urn:schemas-microsoft-com:office:office" xmlns:v="urn:schemas-microsoft-com:vml" xmlns:pvml="urn:schemas-microsoft-com:office:powerpoint" xmlns:com="http://schemas.openxmlformats.org/drawingml/2006/compatibility" xmlns:p15="http://schemas.microsoft.com/office/powerpoint/2012/main" xmlns:ahyp="http://schemas.microsoft.com/office/drawing/2018/hyperlinkcolor">
+    <mc:Fallback xmlns:ahyp="http://schemas.microsoft.com/office/drawing/2018/hyperlinkcolor" xmlns:p15="http://schemas.microsoft.com/office/powerpoint/2012/main" xmlns:com="http://schemas.openxmlformats.org/drawingml/2006/compatibility" xmlns:pvml="urn:schemas-microsoft-com:office:powerpoint" xmlns:v="urn:schemas-microsoft-com:vml" xmlns:o="urn:schemas-microsoft-com:office:office" xmlns:dgm="http://schemas.openxmlformats.org/drawingml/2006/diagram" xmlns:c="http://schemas.openxmlformats.org/drawingml/2006/chart" xmlns:mv="urn:schemas-microsoft-com:mac:vml" xmlns="">
       <p:transition spd="med">
         <p:fade/>
       </p:transition>
@@ -21027,7 +20863,7 @@
         <p14:reveal/>
       </p:transition>
     </mc:Choice>
-    <mc:Fallback xmlns="" xmlns:mv="urn:schemas-microsoft-com:mac:vml" xmlns:c="http://schemas.openxmlformats.org/drawingml/2006/chart" xmlns:dgm="http://schemas.openxmlformats.org/drawingml/2006/diagram" xmlns:o="urn:schemas-microsoft-com:office:office" xmlns:v="urn:schemas-microsoft-com:vml" xmlns:pvml="urn:schemas-microsoft-com:office:powerpoint" xmlns:com="http://schemas.openxmlformats.org/drawingml/2006/compatibility" xmlns:p15="http://schemas.microsoft.com/office/powerpoint/2012/main" xmlns:ahyp="http://schemas.microsoft.com/office/drawing/2018/hyperlinkcolor">
+    <mc:Fallback xmlns:ahyp="http://schemas.microsoft.com/office/drawing/2018/hyperlinkcolor" xmlns:p15="http://schemas.microsoft.com/office/powerpoint/2012/main" xmlns:com="http://schemas.openxmlformats.org/drawingml/2006/compatibility" xmlns:pvml="urn:schemas-microsoft-com:office:powerpoint" xmlns:v="urn:schemas-microsoft-com:vml" xmlns:o="urn:schemas-microsoft-com:office:office" xmlns:dgm="http://schemas.openxmlformats.org/drawingml/2006/diagram" xmlns:c="http://schemas.openxmlformats.org/drawingml/2006/chart" xmlns:mv="urn:schemas-microsoft-com:mac:vml" xmlns="">
       <p:transition spd="med">
         <p:fade/>
       </p:transition>
@@ -21158,7 +20994,7 @@
         <p14:reveal/>
       </p:transition>
     </mc:Choice>
-    <mc:Fallback xmlns="" xmlns:mv="urn:schemas-microsoft-com:mac:vml" xmlns:c="http://schemas.openxmlformats.org/drawingml/2006/chart" xmlns:dgm="http://schemas.openxmlformats.org/drawingml/2006/diagram" xmlns:o="urn:schemas-microsoft-com:office:office" xmlns:v="urn:schemas-microsoft-com:vml" xmlns:pvml="urn:schemas-microsoft-com:office:powerpoint" xmlns:com="http://schemas.openxmlformats.org/drawingml/2006/compatibility" xmlns:p15="http://schemas.microsoft.com/office/powerpoint/2012/main" xmlns:ahyp="http://schemas.microsoft.com/office/drawing/2018/hyperlinkcolor">
+    <mc:Fallback xmlns:ahyp="http://schemas.microsoft.com/office/drawing/2018/hyperlinkcolor" xmlns:p15="http://schemas.microsoft.com/office/powerpoint/2012/main" xmlns:com="http://schemas.openxmlformats.org/drawingml/2006/compatibility" xmlns:pvml="urn:schemas-microsoft-com:office:powerpoint" xmlns:v="urn:schemas-microsoft-com:vml" xmlns:o="urn:schemas-microsoft-com:office:office" xmlns:dgm="http://schemas.openxmlformats.org/drawingml/2006/diagram" xmlns:c="http://schemas.openxmlformats.org/drawingml/2006/chart" xmlns:mv="urn:schemas-microsoft-com:mac:vml" xmlns="">
       <p:transition spd="med">
         <p:fade/>
       </p:transition>
@@ -21347,7 +21183,7 @@
         <p14:reveal/>
       </p:transition>
     </mc:Choice>
-    <mc:Fallback xmlns="" xmlns:mv="urn:schemas-microsoft-com:mac:vml" xmlns:c="http://schemas.openxmlformats.org/drawingml/2006/chart" xmlns:dgm="http://schemas.openxmlformats.org/drawingml/2006/diagram" xmlns:o="urn:schemas-microsoft-com:office:office" xmlns:v="urn:schemas-microsoft-com:vml" xmlns:pvml="urn:schemas-microsoft-com:office:powerpoint" xmlns:com="http://schemas.openxmlformats.org/drawingml/2006/compatibility" xmlns:p15="http://schemas.microsoft.com/office/powerpoint/2012/main" xmlns:ahyp="http://schemas.microsoft.com/office/drawing/2018/hyperlinkcolor">
+    <mc:Fallback xmlns:ahyp="http://schemas.microsoft.com/office/drawing/2018/hyperlinkcolor" xmlns:p15="http://schemas.microsoft.com/office/powerpoint/2012/main" xmlns:com="http://schemas.openxmlformats.org/drawingml/2006/compatibility" xmlns:pvml="urn:schemas-microsoft-com:office:powerpoint" xmlns:v="urn:schemas-microsoft-com:vml" xmlns:o="urn:schemas-microsoft-com:office:office" xmlns:dgm="http://schemas.openxmlformats.org/drawingml/2006/diagram" xmlns:c="http://schemas.openxmlformats.org/drawingml/2006/chart" xmlns:mv="urn:schemas-microsoft-com:mac:vml" xmlns="">
       <p:transition spd="med">
         <p:fade/>
       </p:transition>
@@ -21763,7 +21599,7 @@
         <p14:reveal/>
       </p:transition>
     </mc:Choice>
-    <mc:Fallback xmlns="" xmlns:mv="urn:schemas-microsoft-com:mac:vml" xmlns:c="http://schemas.openxmlformats.org/drawingml/2006/chart" xmlns:dgm="http://schemas.openxmlformats.org/drawingml/2006/diagram" xmlns:o="urn:schemas-microsoft-com:office:office" xmlns:v="urn:schemas-microsoft-com:vml" xmlns:pvml="urn:schemas-microsoft-com:office:powerpoint" xmlns:com="http://schemas.openxmlformats.org/drawingml/2006/compatibility" xmlns:p15="http://schemas.microsoft.com/office/powerpoint/2012/main" xmlns:ahyp="http://schemas.microsoft.com/office/drawing/2018/hyperlinkcolor">
+    <mc:Fallback xmlns:ahyp="http://schemas.microsoft.com/office/drawing/2018/hyperlinkcolor" xmlns:p15="http://schemas.microsoft.com/office/powerpoint/2012/main" xmlns:com="http://schemas.openxmlformats.org/drawingml/2006/compatibility" xmlns:pvml="urn:schemas-microsoft-com:office:powerpoint" xmlns:v="urn:schemas-microsoft-com:vml" xmlns:o="urn:schemas-microsoft-com:office:office" xmlns:dgm="http://schemas.openxmlformats.org/drawingml/2006/diagram" xmlns:c="http://schemas.openxmlformats.org/drawingml/2006/chart" xmlns:mv="urn:schemas-microsoft-com:mac:vml" xmlns="">
       <p:transition spd="med">
         <p:fade/>
       </p:transition>
@@ -22042,7 +21878,7 @@
         <p14:reveal/>
       </p:transition>
     </mc:Choice>
-    <mc:Fallback xmlns="" xmlns:mv="urn:schemas-microsoft-com:mac:vml" xmlns:c="http://schemas.openxmlformats.org/drawingml/2006/chart" xmlns:dgm="http://schemas.openxmlformats.org/drawingml/2006/diagram" xmlns:o="urn:schemas-microsoft-com:office:office" xmlns:v="urn:schemas-microsoft-com:vml" xmlns:pvml="urn:schemas-microsoft-com:office:powerpoint" xmlns:com="http://schemas.openxmlformats.org/drawingml/2006/compatibility" xmlns:p15="http://schemas.microsoft.com/office/powerpoint/2012/main" xmlns:ahyp="http://schemas.microsoft.com/office/drawing/2018/hyperlinkcolor">
+    <mc:Fallback xmlns:ahyp="http://schemas.microsoft.com/office/drawing/2018/hyperlinkcolor" xmlns:p15="http://schemas.microsoft.com/office/powerpoint/2012/main" xmlns:com="http://schemas.openxmlformats.org/drawingml/2006/compatibility" xmlns:pvml="urn:schemas-microsoft-com:office:powerpoint" xmlns:v="urn:schemas-microsoft-com:vml" xmlns:o="urn:schemas-microsoft-com:office:office" xmlns:dgm="http://schemas.openxmlformats.org/drawingml/2006/diagram" xmlns:c="http://schemas.openxmlformats.org/drawingml/2006/chart" xmlns:mv="urn:schemas-microsoft-com:mac:vml" xmlns="">
       <p:transition spd="med">
         <p:fade/>
       </p:transition>
@@ -24339,7 +24175,7 @@
         <p14:reveal/>
       </p:transition>
     </mc:Choice>
-    <mc:Fallback xmlns="" xmlns:mv="urn:schemas-microsoft-com:mac:vml" xmlns:c="http://schemas.openxmlformats.org/drawingml/2006/chart" xmlns:dgm="http://schemas.openxmlformats.org/drawingml/2006/diagram" xmlns:o="urn:schemas-microsoft-com:office:office" xmlns:v="urn:schemas-microsoft-com:vml" xmlns:pvml="urn:schemas-microsoft-com:office:powerpoint" xmlns:com="http://schemas.openxmlformats.org/drawingml/2006/compatibility" xmlns:p15="http://schemas.microsoft.com/office/powerpoint/2012/main" xmlns:ahyp="http://schemas.microsoft.com/office/drawing/2018/hyperlinkcolor">
+    <mc:Fallback xmlns:ahyp="http://schemas.microsoft.com/office/drawing/2018/hyperlinkcolor" xmlns:p15="http://schemas.microsoft.com/office/powerpoint/2012/main" xmlns:com="http://schemas.openxmlformats.org/drawingml/2006/compatibility" xmlns:pvml="urn:schemas-microsoft-com:office:powerpoint" xmlns:v="urn:schemas-microsoft-com:vml" xmlns:o="urn:schemas-microsoft-com:office:office" xmlns:dgm="http://schemas.openxmlformats.org/drawingml/2006/diagram" xmlns:c="http://schemas.openxmlformats.org/drawingml/2006/chart" xmlns:mv="urn:schemas-microsoft-com:mac:vml" xmlns="">
       <p:transition spd="med">
         <p:fade/>
       </p:transition>
@@ -24547,7 +24383,7 @@
         <p14:reveal/>
       </p:transition>
     </mc:Choice>
-    <mc:Fallback xmlns="" xmlns:mv="urn:schemas-microsoft-com:mac:vml" xmlns:c="http://schemas.openxmlformats.org/drawingml/2006/chart" xmlns:dgm="http://schemas.openxmlformats.org/drawingml/2006/diagram" xmlns:o="urn:schemas-microsoft-com:office:office" xmlns:v="urn:schemas-microsoft-com:vml" xmlns:pvml="urn:schemas-microsoft-com:office:powerpoint" xmlns:com="http://schemas.openxmlformats.org/drawingml/2006/compatibility" xmlns:p15="http://schemas.microsoft.com/office/powerpoint/2012/main" xmlns:ahyp="http://schemas.microsoft.com/office/drawing/2018/hyperlinkcolor">
+    <mc:Fallback xmlns:ahyp="http://schemas.microsoft.com/office/drawing/2018/hyperlinkcolor" xmlns:p15="http://schemas.microsoft.com/office/powerpoint/2012/main" xmlns:com="http://schemas.openxmlformats.org/drawingml/2006/compatibility" xmlns:pvml="urn:schemas-microsoft-com:office:powerpoint" xmlns:v="urn:schemas-microsoft-com:vml" xmlns:o="urn:schemas-microsoft-com:office:office" xmlns:dgm="http://schemas.openxmlformats.org/drawingml/2006/diagram" xmlns:c="http://schemas.openxmlformats.org/drawingml/2006/chart" xmlns:mv="urn:schemas-microsoft-com:mac:vml" xmlns="">
       <p:transition spd="med">
         <p:fade/>
       </p:transition>
@@ -24968,7 +24804,7 @@
         <p14:reveal/>
       </p:transition>
     </mc:Choice>
-    <mc:Fallback xmlns="" xmlns:mv="urn:schemas-microsoft-com:mac:vml" xmlns:c="http://schemas.openxmlformats.org/drawingml/2006/chart" xmlns:dgm="http://schemas.openxmlformats.org/drawingml/2006/diagram" xmlns:o="urn:schemas-microsoft-com:office:office" xmlns:v="urn:schemas-microsoft-com:vml" xmlns:pvml="urn:schemas-microsoft-com:office:powerpoint" xmlns:com="http://schemas.openxmlformats.org/drawingml/2006/compatibility" xmlns:p15="http://schemas.microsoft.com/office/powerpoint/2012/main" xmlns:ahyp="http://schemas.microsoft.com/office/drawing/2018/hyperlinkcolor">
+    <mc:Fallback xmlns:ahyp="http://schemas.microsoft.com/office/drawing/2018/hyperlinkcolor" xmlns:p15="http://schemas.microsoft.com/office/powerpoint/2012/main" xmlns:com="http://schemas.openxmlformats.org/drawingml/2006/compatibility" xmlns:pvml="urn:schemas-microsoft-com:office:powerpoint" xmlns:v="urn:schemas-microsoft-com:vml" xmlns:o="urn:schemas-microsoft-com:office:office" xmlns:dgm="http://schemas.openxmlformats.org/drawingml/2006/diagram" xmlns:c="http://schemas.openxmlformats.org/drawingml/2006/chart" xmlns:mv="urn:schemas-microsoft-com:mac:vml" xmlns="">
       <p:transition spd="med">
         <p:fade/>
       </p:transition>
@@ -25299,7 +25135,7 @@
         <p14:reveal/>
       </p:transition>
     </mc:Choice>
-    <mc:Fallback xmlns="" xmlns:mv="urn:schemas-microsoft-com:mac:vml" xmlns:c="http://schemas.openxmlformats.org/drawingml/2006/chart" xmlns:dgm="http://schemas.openxmlformats.org/drawingml/2006/diagram" xmlns:o="urn:schemas-microsoft-com:office:office" xmlns:v="urn:schemas-microsoft-com:vml" xmlns:pvml="urn:schemas-microsoft-com:office:powerpoint" xmlns:com="http://schemas.openxmlformats.org/drawingml/2006/compatibility" xmlns:p15="http://schemas.microsoft.com/office/powerpoint/2012/main" xmlns:ahyp="http://schemas.microsoft.com/office/drawing/2018/hyperlinkcolor">
+    <mc:Fallback xmlns:ahyp="http://schemas.microsoft.com/office/drawing/2018/hyperlinkcolor" xmlns:p15="http://schemas.microsoft.com/office/powerpoint/2012/main" xmlns:com="http://schemas.openxmlformats.org/drawingml/2006/compatibility" xmlns:pvml="urn:schemas-microsoft-com:office:powerpoint" xmlns:v="urn:schemas-microsoft-com:vml" xmlns:o="urn:schemas-microsoft-com:office:office" xmlns:dgm="http://schemas.openxmlformats.org/drawingml/2006/diagram" xmlns:c="http://schemas.openxmlformats.org/drawingml/2006/chart" xmlns:mv="urn:schemas-microsoft-com:mac:vml" xmlns="">
       <p:transition spd="med">
         <p:fade/>
       </p:transition>
@@ -25468,7 +25304,7 @@
         <p14:reveal/>
       </p:transition>
     </mc:Choice>
-    <mc:Fallback xmlns="" xmlns:mv="urn:schemas-microsoft-com:mac:vml" xmlns:c="http://schemas.openxmlformats.org/drawingml/2006/chart" xmlns:dgm="http://schemas.openxmlformats.org/drawingml/2006/diagram" xmlns:o="urn:schemas-microsoft-com:office:office" xmlns:v="urn:schemas-microsoft-com:vml" xmlns:pvml="urn:schemas-microsoft-com:office:powerpoint" xmlns:com="http://schemas.openxmlformats.org/drawingml/2006/compatibility" xmlns:p15="http://schemas.microsoft.com/office/powerpoint/2012/main" xmlns:ahyp="http://schemas.microsoft.com/office/drawing/2018/hyperlinkcolor">
+    <mc:Fallback xmlns:ahyp="http://schemas.microsoft.com/office/drawing/2018/hyperlinkcolor" xmlns:p15="http://schemas.microsoft.com/office/powerpoint/2012/main" xmlns:com="http://schemas.openxmlformats.org/drawingml/2006/compatibility" xmlns:pvml="urn:schemas-microsoft-com:office:powerpoint" xmlns:v="urn:schemas-microsoft-com:vml" xmlns:o="urn:schemas-microsoft-com:office:office" xmlns:dgm="http://schemas.openxmlformats.org/drawingml/2006/diagram" xmlns:c="http://schemas.openxmlformats.org/drawingml/2006/chart" xmlns:mv="urn:schemas-microsoft-com:mac:vml" xmlns="">
       <p:transition spd="med">
         <p:fade/>
       </p:transition>
@@ -25883,7 +25719,7 @@
         <p14:reveal/>
       </p:transition>
     </mc:Choice>
-    <mc:Fallback xmlns="" xmlns:mv="urn:schemas-microsoft-com:mac:vml" xmlns:c="http://schemas.openxmlformats.org/drawingml/2006/chart" xmlns:dgm="http://schemas.openxmlformats.org/drawingml/2006/diagram" xmlns:o="urn:schemas-microsoft-com:office:office" xmlns:v="urn:schemas-microsoft-com:vml" xmlns:pvml="urn:schemas-microsoft-com:office:powerpoint" xmlns:com="http://schemas.openxmlformats.org/drawingml/2006/compatibility" xmlns:p15="http://schemas.microsoft.com/office/powerpoint/2012/main" xmlns:ahyp="http://schemas.microsoft.com/office/drawing/2018/hyperlinkcolor">
+    <mc:Fallback xmlns:ahyp="http://schemas.microsoft.com/office/drawing/2018/hyperlinkcolor" xmlns:p15="http://schemas.microsoft.com/office/powerpoint/2012/main" xmlns:com="http://schemas.openxmlformats.org/drawingml/2006/compatibility" xmlns:pvml="urn:schemas-microsoft-com:office:powerpoint" xmlns:v="urn:schemas-microsoft-com:vml" xmlns:o="urn:schemas-microsoft-com:office:office" xmlns:dgm="http://schemas.openxmlformats.org/drawingml/2006/diagram" xmlns:c="http://schemas.openxmlformats.org/drawingml/2006/chart" xmlns:mv="urn:schemas-microsoft-com:mac:vml" xmlns="">
       <p:transition spd="med">
         <p:fade/>
       </p:transition>
@@ -26012,7 +25848,7 @@
         <p14:reveal/>
       </p:transition>
     </mc:Choice>
-    <mc:Fallback xmlns="" xmlns:mv="urn:schemas-microsoft-com:mac:vml" xmlns:c="http://schemas.openxmlformats.org/drawingml/2006/chart" xmlns:dgm="http://schemas.openxmlformats.org/drawingml/2006/diagram" xmlns:o="urn:schemas-microsoft-com:office:office" xmlns:v="urn:schemas-microsoft-com:vml" xmlns:pvml="urn:schemas-microsoft-com:office:powerpoint" xmlns:com="http://schemas.openxmlformats.org/drawingml/2006/compatibility" xmlns:p15="http://schemas.microsoft.com/office/powerpoint/2012/main" xmlns:ahyp="http://schemas.microsoft.com/office/drawing/2018/hyperlinkcolor">
+    <mc:Fallback xmlns:ahyp="http://schemas.microsoft.com/office/drawing/2018/hyperlinkcolor" xmlns:p15="http://schemas.microsoft.com/office/powerpoint/2012/main" xmlns:com="http://schemas.openxmlformats.org/drawingml/2006/compatibility" xmlns:pvml="urn:schemas-microsoft-com:office:powerpoint" xmlns:v="urn:schemas-microsoft-com:vml" xmlns:o="urn:schemas-microsoft-com:office:office" xmlns:dgm="http://schemas.openxmlformats.org/drawingml/2006/diagram" xmlns:c="http://schemas.openxmlformats.org/drawingml/2006/chart" xmlns:mv="urn:schemas-microsoft-com:mac:vml" xmlns="">
       <p:transition spd="med">
         <p:fade/>
       </p:transition>
@@ -26334,7 +26170,7 @@
         <p14:reveal/>
       </p:transition>
     </mc:Choice>
-    <mc:Fallback xmlns="" xmlns:mv="urn:schemas-microsoft-com:mac:vml" xmlns:c="http://schemas.openxmlformats.org/drawingml/2006/chart" xmlns:dgm="http://schemas.openxmlformats.org/drawingml/2006/diagram" xmlns:o="urn:schemas-microsoft-com:office:office" xmlns:v="urn:schemas-microsoft-com:vml" xmlns:pvml="urn:schemas-microsoft-com:office:powerpoint" xmlns:com="http://schemas.openxmlformats.org/drawingml/2006/compatibility" xmlns:p15="http://schemas.microsoft.com/office/powerpoint/2012/main" xmlns:ahyp="http://schemas.microsoft.com/office/drawing/2018/hyperlinkcolor">
+    <mc:Fallback xmlns:ahyp="http://schemas.microsoft.com/office/drawing/2018/hyperlinkcolor" xmlns:p15="http://schemas.microsoft.com/office/powerpoint/2012/main" xmlns:com="http://schemas.openxmlformats.org/drawingml/2006/compatibility" xmlns:pvml="urn:schemas-microsoft-com:office:powerpoint" xmlns:v="urn:schemas-microsoft-com:vml" xmlns:o="urn:schemas-microsoft-com:office:office" xmlns:dgm="http://schemas.openxmlformats.org/drawingml/2006/diagram" xmlns:c="http://schemas.openxmlformats.org/drawingml/2006/chart" xmlns:mv="urn:schemas-microsoft-com:mac:vml" xmlns="">
       <p:transition spd="med">
         <p:fade/>
       </p:transition>
@@ -26668,7 +26504,7 @@
         <p14:reveal/>
       </p:transition>
     </mc:Choice>
-    <mc:Fallback xmlns="" xmlns:mv="urn:schemas-microsoft-com:mac:vml" xmlns:c="http://schemas.openxmlformats.org/drawingml/2006/chart" xmlns:dgm="http://schemas.openxmlformats.org/drawingml/2006/diagram" xmlns:o="urn:schemas-microsoft-com:office:office" xmlns:v="urn:schemas-microsoft-com:vml" xmlns:pvml="urn:schemas-microsoft-com:office:powerpoint" xmlns:com="http://schemas.openxmlformats.org/drawingml/2006/compatibility" xmlns:p15="http://schemas.microsoft.com/office/powerpoint/2012/main" xmlns:ahyp="http://schemas.microsoft.com/office/drawing/2018/hyperlinkcolor">
+    <mc:Fallback xmlns:ahyp="http://schemas.microsoft.com/office/drawing/2018/hyperlinkcolor" xmlns:p15="http://schemas.microsoft.com/office/powerpoint/2012/main" xmlns:com="http://schemas.openxmlformats.org/drawingml/2006/compatibility" xmlns:pvml="urn:schemas-microsoft-com:office:powerpoint" xmlns:v="urn:schemas-microsoft-com:vml" xmlns:o="urn:schemas-microsoft-com:office:office" xmlns:dgm="http://schemas.openxmlformats.org/drawingml/2006/diagram" xmlns:c="http://schemas.openxmlformats.org/drawingml/2006/chart" xmlns:mv="urn:schemas-microsoft-com:mac:vml" xmlns="">
       <p:transition spd="med">
         <p:fade/>
       </p:transition>
@@ -26814,7 +26650,7 @@
         <p14:reveal/>
       </p:transition>
     </mc:Choice>
-    <mc:Fallback xmlns="" xmlns:mv="urn:schemas-microsoft-com:mac:vml" xmlns:c="http://schemas.openxmlformats.org/drawingml/2006/chart" xmlns:dgm="http://schemas.openxmlformats.org/drawingml/2006/diagram" xmlns:o="urn:schemas-microsoft-com:office:office" xmlns:v="urn:schemas-microsoft-com:vml" xmlns:pvml="urn:schemas-microsoft-com:office:powerpoint" xmlns:com="http://schemas.openxmlformats.org/drawingml/2006/compatibility" xmlns:p15="http://schemas.microsoft.com/office/powerpoint/2012/main" xmlns:ahyp="http://schemas.microsoft.com/office/drawing/2018/hyperlinkcolor">
+    <mc:Fallback xmlns:ahyp="http://schemas.microsoft.com/office/drawing/2018/hyperlinkcolor" xmlns:p15="http://schemas.microsoft.com/office/powerpoint/2012/main" xmlns:com="http://schemas.openxmlformats.org/drawingml/2006/compatibility" xmlns:pvml="urn:schemas-microsoft-com:office:powerpoint" xmlns:v="urn:schemas-microsoft-com:vml" xmlns:o="urn:schemas-microsoft-com:office:office" xmlns:dgm="http://schemas.openxmlformats.org/drawingml/2006/diagram" xmlns:c="http://schemas.openxmlformats.org/drawingml/2006/chart" xmlns:mv="urn:schemas-microsoft-com:mac:vml" xmlns="">
       <p:transition spd="med">
         <p:fade/>
       </p:transition>
@@ -28011,7 +27847,7 @@
         <p14:reveal/>
       </p:transition>
     </mc:Choice>
-    <mc:Fallback xmlns="" xmlns:mv="urn:schemas-microsoft-com:mac:vml" xmlns:c="http://schemas.openxmlformats.org/drawingml/2006/chart" xmlns:dgm="http://schemas.openxmlformats.org/drawingml/2006/diagram" xmlns:o="urn:schemas-microsoft-com:office:office" xmlns:v="urn:schemas-microsoft-com:vml" xmlns:pvml="urn:schemas-microsoft-com:office:powerpoint" xmlns:com="http://schemas.openxmlformats.org/drawingml/2006/compatibility" xmlns:p15="http://schemas.microsoft.com/office/powerpoint/2012/main" xmlns:ahyp="http://schemas.microsoft.com/office/drawing/2018/hyperlinkcolor">
+    <mc:Fallback xmlns:ahyp="http://schemas.microsoft.com/office/drawing/2018/hyperlinkcolor" xmlns:p15="http://schemas.microsoft.com/office/powerpoint/2012/main" xmlns:com="http://schemas.openxmlformats.org/drawingml/2006/compatibility" xmlns:pvml="urn:schemas-microsoft-com:office:powerpoint" xmlns:v="urn:schemas-microsoft-com:vml" xmlns:o="urn:schemas-microsoft-com:office:office" xmlns:dgm="http://schemas.openxmlformats.org/drawingml/2006/diagram" xmlns:c="http://schemas.openxmlformats.org/drawingml/2006/chart" xmlns:mv="urn:schemas-microsoft-com:mac:vml" xmlns="">
       <p:transition spd="med">
         <p:fade/>
       </p:transition>
@@ -28345,7 +28181,7 @@
         <p14:reveal/>
       </p:transition>
     </mc:Choice>
-    <mc:Fallback xmlns="" xmlns:mv="urn:schemas-microsoft-com:mac:vml" xmlns:c="http://schemas.openxmlformats.org/drawingml/2006/chart" xmlns:dgm="http://schemas.openxmlformats.org/drawingml/2006/diagram" xmlns:o="urn:schemas-microsoft-com:office:office" xmlns:v="urn:schemas-microsoft-com:vml" xmlns:pvml="urn:schemas-microsoft-com:office:powerpoint" xmlns:com="http://schemas.openxmlformats.org/drawingml/2006/compatibility" xmlns:p15="http://schemas.microsoft.com/office/powerpoint/2012/main" xmlns:ahyp="http://schemas.microsoft.com/office/drawing/2018/hyperlinkcolor">
+    <mc:Fallback xmlns:ahyp="http://schemas.microsoft.com/office/drawing/2018/hyperlinkcolor" xmlns:p15="http://schemas.microsoft.com/office/powerpoint/2012/main" xmlns:com="http://schemas.openxmlformats.org/drawingml/2006/compatibility" xmlns:pvml="urn:schemas-microsoft-com:office:powerpoint" xmlns:v="urn:schemas-microsoft-com:vml" xmlns:o="urn:schemas-microsoft-com:office:office" xmlns:dgm="http://schemas.openxmlformats.org/drawingml/2006/diagram" xmlns:c="http://schemas.openxmlformats.org/drawingml/2006/chart" xmlns:mv="urn:schemas-microsoft-com:mac:vml" xmlns="">
       <p:transition spd="med">
         <p:fade/>
       </p:transition>
@@ -28699,7 +28535,7 @@
         <p14:reveal/>
       </p:transition>
     </mc:Choice>
-    <mc:Fallback xmlns="" xmlns:mv="urn:schemas-microsoft-com:mac:vml" xmlns:c="http://schemas.openxmlformats.org/drawingml/2006/chart" xmlns:dgm="http://schemas.openxmlformats.org/drawingml/2006/diagram" xmlns:o="urn:schemas-microsoft-com:office:office" xmlns:v="urn:schemas-microsoft-com:vml" xmlns:pvml="urn:schemas-microsoft-com:office:powerpoint" xmlns:com="http://schemas.openxmlformats.org/drawingml/2006/compatibility" xmlns:p15="http://schemas.microsoft.com/office/powerpoint/2012/main" xmlns:ahyp="http://schemas.microsoft.com/office/drawing/2018/hyperlinkcolor">
+    <mc:Fallback xmlns:ahyp="http://schemas.microsoft.com/office/drawing/2018/hyperlinkcolor" xmlns:p15="http://schemas.microsoft.com/office/powerpoint/2012/main" xmlns:com="http://schemas.openxmlformats.org/drawingml/2006/compatibility" xmlns:pvml="urn:schemas-microsoft-com:office:powerpoint" xmlns:v="urn:schemas-microsoft-com:vml" xmlns:o="urn:schemas-microsoft-com:office:office" xmlns:dgm="http://schemas.openxmlformats.org/drawingml/2006/diagram" xmlns:c="http://schemas.openxmlformats.org/drawingml/2006/chart" xmlns:mv="urn:schemas-microsoft-com:mac:vml" xmlns="">
       <p:transition spd="med">
         <p:fade/>
       </p:transition>
@@ -29063,7 +28899,7 @@
         <p14:reveal/>
       </p:transition>
     </mc:Choice>
-    <mc:Fallback xmlns="" xmlns:mv="urn:schemas-microsoft-com:mac:vml" xmlns:c="http://schemas.openxmlformats.org/drawingml/2006/chart" xmlns:dgm="http://schemas.openxmlformats.org/drawingml/2006/diagram" xmlns:o="urn:schemas-microsoft-com:office:office" xmlns:v="urn:schemas-microsoft-com:vml" xmlns:pvml="urn:schemas-microsoft-com:office:powerpoint" xmlns:com="http://schemas.openxmlformats.org/drawingml/2006/compatibility" xmlns:p15="http://schemas.microsoft.com/office/powerpoint/2012/main" xmlns:ahyp="http://schemas.microsoft.com/office/drawing/2018/hyperlinkcolor">
+    <mc:Fallback xmlns:ahyp="http://schemas.microsoft.com/office/drawing/2018/hyperlinkcolor" xmlns:p15="http://schemas.microsoft.com/office/powerpoint/2012/main" xmlns:com="http://schemas.openxmlformats.org/drawingml/2006/compatibility" xmlns:pvml="urn:schemas-microsoft-com:office:powerpoint" xmlns:v="urn:schemas-microsoft-com:vml" xmlns:o="urn:schemas-microsoft-com:office:office" xmlns:dgm="http://schemas.openxmlformats.org/drawingml/2006/diagram" xmlns:c="http://schemas.openxmlformats.org/drawingml/2006/chart" xmlns:mv="urn:schemas-microsoft-com:mac:vml" xmlns="">
       <p:transition spd="med">
         <p:fade/>
       </p:transition>
@@ -29328,7 +29164,7 @@
         <p14:reveal/>
       </p:transition>
     </mc:Choice>
-    <mc:Fallback xmlns="" xmlns:mv="urn:schemas-microsoft-com:mac:vml" xmlns:c="http://schemas.openxmlformats.org/drawingml/2006/chart" xmlns:dgm="http://schemas.openxmlformats.org/drawingml/2006/diagram" xmlns:o="urn:schemas-microsoft-com:office:office" xmlns:v="urn:schemas-microsoft-com:vml" xmlns:pvml="urn:schemas-microsoft-com:office:powerpoint" xmlns:com="http://schemas.openxmlformats.org/drawingml/2006/compatibility" xmlns:p15="http://schemas.microsoft.com/office/powerpoint/2012/main" xmlns:ahyp="http://schemas.microsoft.com/office/drawing/2018/hyperlinkcolor">
+    <mc:Fallback xmlns:ahyp="http://schemas.microsoft.com/office/drawing/2018/hyperlinkcolor" xmlns:p15="http://schemas.microsoft.com/office/powerpoint/2012/main" xmlns:com="http://schemas.openxmlformats.org/drawingml/2006/compatibility" xmlns:pvml="urn:schemas-microsoft-com:office:powerpoint" xmlns:v="urn:schemas-microsoft-com:vml" xmlns:o="urn:schemas-microsoft-com:office:office" xmlns:dgm="http://schemas.openxmlformats.org/drawingml/2006/diagram" xmlns:c="http://schemas.openxmlformats.org/drawingml/2006/chart" xmlns:mv="urn:schemas-microsoft-com:mac:vml" xmlns="">
       <p:transition spd="med">
         <p:fade/>
       </p:transition>
@@ -29641,7 +29477,7 @@
         <p14:reveal/>
       </p:transition>
     </mc:Choice>
-    <mc:Fallback xmlns="" xmlns:mv="urn:schemas-microsoft-com:mac:vml" xmlns:c="http://schemas.openxmlformats.org/drawingml/2006/chart" xmlns:dgm="http://schemas.openxmlformats.org/drawingml/2006/diagram" xmlns:o="urn:schemas-microsoft-com:office:office" xmlns:v="urn:schemas-microsoft-com:vml" xmlns:pvml="urn:schemas-microsoft-com:office:powerpoint" xmlns:com="http://schemas.openxmlformats.org/drawingml/2006/compatibility" xmlns:p15="http://schemas.microsoft.com/office/powerpoint/2012/main" xmlns:ahyp="http://schemas.microsoft.com/office/drawing/2018/hyperlinkcolor">
+    <mc:Fallback xmlns:ahyp="http://schemas.microsoft.com/office/drawing/2018/hyperlinkcolor" xmlns:p15="http://schemas.microsoft.com/office/powerpoint/2012/main" xmlns:com="http://schemas.openxmlformats.org/drawingml/2006/compatibility" xmlns:pvml="urn:schemas-microsoft-com:office:powerpoint" xmlns:v="urn:schemas-microsoft-com:vml" xmlns:o="urn:schemas-microsoft-com:office:office" xmlns:dgm="http://schemas.openxmlformats.org/drawingml/2006/diagram" xmlns:c="http://schemas.openxmlformats.org/drawingml/2006/chart" xmlns:mv="urn:schemas-microsoft-com:mac:vml" xmlns="">
       <p:transition spd="med">
         <p:fade/>
       </p:transition>
@@ -30026,7 +29862,7 @@
         <p14:reveal/>
       </p:transition>
     </mc:Choice>
-    <mc:Fallback xmlns="" xmlns:mv="urn:schemas-microsoft-com:mac:vml" xmlns:c="http://schemas.openxmlformats.org/drawingml/2006/chart" xmlns:dgm="http://schemas.openxmlformats.org/drawingml/2006/diagram" xmlns:o="urn:schemas-microsoft-com:office:office" xmlns:v="urn:schemas-microsoft-com:vml" xmlns:pvml="urn:schemas-microsoft-com:office:powerpoint" xmlns:com="http://schemas.openxmlformats.org/drawingml/2006/compatibility" xmlns:p15="http://schemas.microsoft.com/office/powerpoint/2012/main" xmlns:ahyp="http://schemas.microsoft.com/office/drawing/2018/hyperlinkcolor">
+    <mc:Fallback xmlns:ahyp="http://schemas.microsoft.com/office/drawing/2018/hyperlinkcolor" xmlns:p15="http://schemas.microsoft.com/office/powerpoint/2012/main" xmlns:com="http://schemas.openxmlformats.org/drawingml/2006/compatibility" xmlns:pvml="urn:schemas-microsoft-com:office:powerpoint" xmlns:v="urn:schemas-microsoft-com:vml" xmlns:o="urn:schemas-microsoft-com:office:office" xmlns:dgm="http://schemas.openxmlformats.org/drawingml/2006/diagram" xmlns:c="http://schemas.openxmlformats.org/drawingml/2006/chart" xmlns:mv="urn:schemas-microsoft-com:mac:vml" xmlns="">
       <p:transition spd="med">
         <p:fade/>
       </p:transition>
@@ -30266,7 +30102,7 @@
         <p14:reveal/>
       </p:transition>
     </mc:Choice>
-    <mc:Fallback xmlns="" xmlns:mv="urn:schemas-microsoft-com:mac:vml" xmlns:c="http://schemas.openxmlformats.org/drawingml/2006/chart" xmlns:dgm="http://schemas.openxmlformats.org/drawingml/2006/diagram" xmlns:o="urn:schemas-microsoft-com:office:office" xmlns:v="urn:schemas-microsoft-com:vml" xmlns:pvml="urn:schemas-microsoft-com:office:powerpoint" xmlns:com="http://schemas.openxmlformats.org/drawingml/2006/compatibility" xmlns:p15="http://schemas.microsoft.com/office/powerpoint/2012/main" xmlns:ahyp="http://schemas.microsoft.com/office/drawing/2018/hyperlinkcolor">
+    <mc:Fallback xmlns:ahyp="http://schemas.microsoft.com/office/drawing/2018/hyperlinkcolor" xmlns:p15="http://schemas.microsoft.com/office/powerpoint/2012/main" xmlns:com="http://schemas.openxmlformats.org/drawingml/2006/compatibility" xmlns:pvml="urn:schemas-microsoft-com:office:powerpoint" xmlns:v="urn:schemas-microsoft-com:vml" xmlns:o="urn:schemas-microsoft-com:office:office" xmlns:dgm="http://schemas.openxmlformats.org/drawingml/2006/diagram" xmlns:c="http://schemas.openxmlformats.org/drawingml/2006/chart" xmlns:mv="urn:schemas-microsoft-com:mac:vml" xmlns="">
       <p:transition spd="med">
         <p:fade/>
       </p:transition>
@@ -30510,7 +30346,7 @@
         <p14:reveal/>
       </p:transition>
     </mc:Choice>
-    <mc:Fallback xmlns="" xmlns:mv="urn:schemas-microsoft-com:mac:vml" xmlns:c="http://schemas.openxmlformats.org/drawingml/2006/chart" xmlns:dgm="http://schemas.openxmlformats.org/drawingml/2006/diagram" xmlns:o="urn:schemas-microsoft-com:office:office" xmlns:v="urn:schemas-microsoft-com:vml" xmlns:pvml="urn:schemas-microsoft-com:office:powerpoint" xmlns:com="http://schemas.openxmlformats.org/drawingml/2006/compatibility" xmlns:p15="http://schemas.microsoft.com/office/powerpoint/2012/main" xmlns:ahyp="http://schemas.microsoft.com/office/drawing/2018/hyperlinkcolor">
+    <mc:Fallback xmlns:ahyp="http://schemas.microsoft.com/office/drawing/2018/hyperlinkcolor" xmlns:p15="http://schemas.microsoft.com/office/powerpoint/2012/main" xmlns:com="http://schemas.openxmlformats.org/drawingml/2006/compatibility" xmlns:pvml="urn:schemas-microsoft-com:office:powerpoint" xmlns:v="urn:schemas-microsoft-com:vml" xmlns:o="urn:schemas-microsoft-com:office:office" xmlns:dgm="http://schemas.openxmlformats.org/drawingml/2006/diagram" xmlns:c="http://schemas.openxmlformats.org/drawingml/2006/chart" xmlns:mv="urn:schemas-microsoft-com:mac:vml" xmlns="">
       <p:transition spd="med">
         <p:fade/>
       </p:transition>
@@ -31114,7 +30950,7 @@
         <p14:reveal/>
       </p:transition>
     </mc:Choice>
-    <mc:Fallback xmlns="" xmlns:mv="urn:schemas-microsoft-com:mac:vml" xmlns:c="http://schemas.openxmlformats.org/drawingml/2006/chart" xmlns:dgm="http://schemas.openxmlformats.org/drawingml/2006/diagram" xmlns:o="urn:schemas-microsoft-com:office:office" xmlns:v="urn:schemas-microsoft-com:vml" xmlns:pvml="urn:schemas-microsoft-com:office:powerpoint" xmlns:com="http://schemas.openxmlformats.org/drawingml/2006/compatibility" xmlns:p15="http://schemas.microsoft.com/office/powerpoint/2012/main" xmlns:ahyp="http://schemas.microsoft.com/office/drawing/2018/hyperlinkcolor">
+    <mc:Fallback xmlns:ahyp="http://schemas.microsoft.com/office/drawing/2018/hyperlinkcolor" xmlns:p15="http://schemas.microsoft.com/office/powerpoint/2012/main" xmlns:com="http://schemas.openxmlformats.org/drawingml/2006/compatibility" xmlns:pvml="urn:schemas-microsoft-com:office:powerpoint" xmlns:v="urn:schemas-microsoft-com:vml" xmlns:o="urn:schemas-microsoft-com:office:office" xmlns:dgm="http://schemas.openxmlformats.org/drawingml/2006/diagram" xmlns:c="http://schemas.openxmlformats.org/drawingml/2006/chart" xmlns:mv="urn:schemas-microsoft-com:mac:vml" xmlns="">
       <p:transition spd="med">
         <p:fade/>
       </p:transition>
@@ -31296,7 +31132,18 @@
               <a:rPr lang="fr-BE"/>
               <a:t>L'emplacement réservé à ce dernier est toujours présent même s'il est caché</a:t>
             </a:r>
-            <a:endParaRPr/>
+          </a:p>
+          <a:p>
+            <a:pPr>
+              <a:buClr>
+                <a:schemeClr val="dk1"/>
+              </a:buClr>
+              <a:buSzPts val="3200"/>
+            </a:pPr>
+            <a:r>
+              <a:rPr lang="fr-BE"/>
+              <a:t>Exo 28</a:t>
+            </a:r>
           </a:p>
         </p:txBody>
       </p:sp>
@@ -31311,7 +31158,7 @@
         <p14:reveal/>
       </p:transition>
     </mc:Choice>
-    <mc:Fallback xmlns="" xmlns:mv="urn:schemas-microsoft-com:mac:vml" xmlns:c="http://schemas.openxmlformats.org/drawingml/2006/chart" xmlns:dgm="http://schemas.openxmlformats.org/drawingml/2006/diagram" xmlns:o="urn:schemas-microsoft-com:office:office" xmlns:v="urn:schemas-microsoft-com:vml" xmlns:pvml="urn:schemas-microsoft-com:office:powerpoint" xmlns:com="http://schemas.openxmlformats.org/drawingml/2006/compatibility" xmlns:p15="http://schemas.microsoft.com/office/powerpoint/2012/main" xmlns:ahyp="http://schemas.microsoft.com/office/drawing/2018/hyperlinkcolor">
+    <mc:Fallback xmlns:ahyp="http://schemas.microsoft.com/office/drawing/2018/hyperlinkcolor" xmlns:p15="http://schemas.microsoft.com/office/powerpoint/2012/main" xmlns:com="http://schemas.openxmlformats.org/drawingml/2006/compatibility" xmlns:pvml="urn:schemas-microsoft-com:office:powerpoint" xmlns:v="urn:schemas-microsoft-com:vml" xmlns:o="urn:schemas-microsoft-com:office:office" xmlns:dgm="http://schemas.openxmlformats.org/drawingml/2006/diagram" xmlns:c="http://schemas.openxmlformats.org/drawingml/2006/chart" xmlns:mv="urn:schemas-microsoft-com:mac:vml" xmlns="">
       <p:transition spd="med">
         <p:fade/>
       </p:transition>
@@ -32283,6 +32130,566 @@
         <p:cNvPr id="1" name="">
           <a:extLst>
             <a:ext uri="{FF2B5EF4-FFF2-40B4-BE49-F238E27FC236}">
+              <a16:creationId xmlns:a16="http://schemas.microsoft.com/office/drawing/2014/main" id="{36E2DD65-D36F-DCB8-6B17-1E2AC309361C}"/>
+            </a:ext>
+          </a:extLst>
+        </p:cNvPr>
+        <p:cNvGrpSpPr/>
+        <p:nvPr/>
+      </p:nvGrpSpPr>
+      <p:grpSpPr>
+        <a:xfrm>
+          <a:off x="0" y="0"/>
+          <a:ext cx="0" cy="0"/>
+          <a:chOff x="0" y="0"/>
+          <a:chExt cx="0" cy="0"/>
+        </a:xfrm>
+      </p:grpSpPr>
+      <p:sp>
+        <p:nvSpPr>
+          <p:cNvPr id="2" name="Titre 1">
+            <a:extLst>
+              <a:ext uri="{FF2B5EF4-FFF2-40B4-BE49-F238E27FC236}">
+                <a16:creationId xmlns:a16="http://schemas.microsoft.com/office/drawing/2014/main" id="{D28547B4-545A-F1CF-713A-F6266044A37D}"/>
+              </a:ext>
+            </a:extLst>
+          </p:cNvPr>
+          <p:cNvSpPr>
+            <a:spLocks noGrp="1"/>
+          </p:cNvSpPr>
+          <p:nvPr>
+            <p:ph type="title"/>
+          </p:nvPr>
+        </p:nvSpPr>
+        <p:spPr/>
+        <p:txBody>
+          <a:bodyPr/>
+          <a:lstStyle/>
+          <a:p>
+            <a:r>
+              <a:rPr lang="fr-BE"/>
+              <a:t>Media &amp; écran : @media </a:t>
+            </a:r>
+          </a:p>
+        </p:txBody>
+      </p:sp>
+      <p:sp>
+        <p:nvSpPr>
+          <p:cNvPr id="3" name="Espace réservé du contenu 2">
+            <a:extLst>
+              <a:ext uri="{FF2B5EF4-FFF2-40B4-BE49-F238E27FC236}">
+                <a16:creationId xmlns:a16="http://schemas.microsoft.com/office/drawing/2014/main" id="{5F6A88E8-0816-5EE6-665A-831AC1947AC2}"/>
+              </a:ext>
+            </a:extLst>
+          </p:cNvPr>
+          <p:cNvSpPr>
+            <a:spLocks noGrp="1"/>
+          </p:cNvSpPr>
+          <p:nvPr>
+            <p:ph sz="half" idx="1"/>
+          </p:nvPr>
+        </p:nvSpPr>
+        <p:spPr>
+          <a:xfrm>
+            <a:off x="838200" y="3628723"/>
+            <a:ext cx="5181600" cy="2618073"/>
+          </a:xfrm>
+        </p:spPr>
+        <p:txBody>
+          <a:bodyPr numCol="1">
+            <a:normAutofit fontScale="85000" lnSpcReduction="20000"/>
+          </a:bodyPr>
+          <a:lstStyle/>
+          <a:p>
+            <a:r>
+              <a:rPr lang="en-US">
+                <a:solidFill>
+                  <a:srgbClr val="996633"/>
+                </a:solidFill>
+                <a:latin typeface="Consolas" panose="020B0609020204030204" pitchFamily="49" charset="0"/>
+              </a:rPr>
+              <a:t>mediatype</a:t>
+            </a:r>
+          </a:p>
+          <a:p>
+            <a:pPr lvl="1"/>
+            <a:r>
+              <a:rPr lang="en-US"/>
+              <a:t>type de support </a:t>
+            </a:r>
+          </a:p>
+          <a:p>
+            <a:pPr lvl="1"/>
+            <a:r>
+              <a:rPr lang="en-US">
+                <a:solidFill>
+                  <a:srgbClr val="996633"/>
+                </a:solidFill>
+                <a:latin typeface="Consolas" panose="020B0609020204030204" pitchFamily="49" charset="0"/>
+              </a:rPr>
+              <a:t>all</a:t>
+            </a:r>
+            <a:r>
+              <a:rPr lang="en-US"/>
+              <a:t> (par défaut)</a:t>
+            </a:r>
+          </a:p>
+          <a:p>
+            <a:pPr lvl="1"/>
+            <a:r>
+              <a:rPr lang="en-US">
+                <a:solidFill>
+                  <a:srgbClr val="996633"/>
+                </a:solidFill>
+                <a:latin typeface="Consolas" panose="020B0609020204030204" pitchFamily="49" charset="0"/>
+              </a:rPr>
+              <a:t>screen</a:t>
+            </a:r>
+          </a:p>
+          <a:p>
+            <a:pPr lvl="1"/>
+            <a:r>
+              <a:rPr lang="en-US">
+                <a:solidFill>
+                  <a:srgbClr val="996633"/>
+                </a:solidFill>
+                <a:latin typeface="Consolas" panose="020B0609020204030204" pitchFamily="49" charset="0"/>
+              </a:rPr>
+              <a:t>print</a:t>
+            </a:r>
+          </a:p>
+          <a:p>
+            <a:pPr lvl="1"/>
+            <a:r>
+              <a:rPr lang="en-US">
+                <a:solidFill>
+                  <a:srgbClr val="996633"/>
+                </a:solidFill>
+                <a:latin typeface="Consolas" panose="020B0609020204030204" pitchFamily="49" charset="0"/>
+              </a:rPr>
+              <a:t>speech</a:t>
+            </a:r>
+          </a:p>
+          <a:p>
+            <a:endParaRPr lang="en-US"/>
+          </a:p>
+          <a:p>
+            <a:pPr marL="457189" lvl="1" indent="0">
+              <a:lnSpc>
+                <a:spcPct val="120000"/>
+              </a:lnSpc>
+              <a:buNone/>
+            </a:pPr>
+            <a:endParaRPr lang="fr-BE"/>
+          </a:p>
+          <a:p>
+            <a:pPr marL="457189" lvl="1" indent="0">
+              <a:lnSpc>
+                <a:spcPct val="120000"/>
+              </a:lnSpc>
+              <a:buNone/>
+            </a:pPr>
+            <a:endParaRPr lang="fr-BE"/>
+          </a:p>
+          <a:p>
+            <a:pPr marL="457189" lvl="1" indent="0">
+              <a:lnSpc>
+                <a:spcPct val="120000"/>
+              </a:lnSpc>
+              <a:buNone/>
+            </a:pPr>
+            <a:endParaRPr lang="fr-BE"/>
+          </a:p>
+        </p:txBody>
+      </p:sp>
+      <p:sp>
+        <p:nvSpPr>
+          <p:cNvPr id="6" name="Espace réservé du contenu 5">
+            <a:extLst>
+              <a:ext uri="{FF2B5EF4-FFF2-40B4-BE49-F238E27FC236}">
+                <a16:creationId xmlns:a16="http://schemas.microsoft.com/office/drawing/2014/main" id="{5C538A8F-AA53-F0A5-B594-4178E6B9423D}"/>
+              </a:ext>
+            </a:extLst>
+          </p:cNvPr>
+          <p:cNvSpPr>
+            <a:spLocks noGrp="1"/>
+          </p:cNvSpPr>
+          <p:nvPr>
+            <p:ph sz="half" idx="2"/>
+          </p:nvPr>
+        </p:nvSpPr>
+        <p:spPr>
+          <a:xfrm>
+            <a:off x="6172200" y="3628723"/>
+            <a:ext cx="5181600" cy="2548242"/>
+          </a:xfrm>
+        </p:spPr>
+        <p:txBody>
+          <a:bodyPr>
+            <a:normAutofit fontScale="85000" lnSpcReduction="20000"/>
+          </a:bodyPr>
+          <a:lstStyle/>
+          <a:p>
+            <a:r>
+              <a:rPr lang="en-US">
+                <a:solidFill>
+                  <a:schemeClr val="accent6">
+                    <a:lumMod val="50000"/>
+                  </a:schemeClr>
+                </a:solidFill>
+                <a:latin typeface="Consolas" panose="020B0609020204030204" pitchFamily="49" charset="0"/>
+              </a:rPr>
+              <a:t>mediafeature</a:t>
+            </a:r>
+          </a:p>
+          <a:p>
+            <a:pPr lvl="1"/>
+            <a:r>
+              <a:rPr lang="fr-BE"/>
+              <a:t>caractéristique du support</a:t>
+            </a:r>
+            <a:endParaRPr lang="en-US">
+              <a:solidFill>
+                <a:schemeClr val="accent6">
+                  <a:lumMod val="50000"/>
+                </a:schemeClr>
+              </a:solidFill>
+              <a:latin typeface="Consolas" panose="020B0609020204030204" pitchFamily="49" charset="0"/>
+            </a:endParaRPr>
+          </a:p>
+          <a:p>
+            <a:pPr lvl="1"/>
+            <a:r>
+              <a:rPr lang="en-US">
+                <a:solidFill>
+                  <a:schemeClr val="accent6">
+                    <a:lumMod val="50000"/>
+                  </a:schemeClr>
+                </a:solidFill>
+                <a:latin typeface="Consolas" panose="020B0609020204030204" pitchFamily="49" charset="0"/>
+              </a:rPr>
+              <a:t>width, max-width, …</a:t>
+            </a:r>
+          </a:p>
+          <a:p>
+            <a:pPr lvl="1"/>
+            <a:r>
+              <a:rPr lang="en-US">
+                <a:solidFill>
+                  <a:schemeClr val="accent6">
+                    <a:lumMod val="50000"/>
+                  </a:schemeClr>
+                </a:solidFill>
+                <a:latin typeface="Consolas" panose="020B0609020204030204" pitchFamily="49" charset="0"/>
+              </a:rPr>
+              <a:t>height, max-height, …</a:t>
+            </a:r>
+          </a:p>
+          <a:p>
+            <a:pPr lvl="1"/>
+            <a:r>
+              <a:rPr lang="en-US">
+                <a:solidFill>
+                  <a:schemeClr val="accent6">
+                    <a:lumMod val="50000"/>
+                  </a:schemeClr>
+                </a:solidFill>
+                <a:latin typeface="Consolas" panose="020B0609020204030204" pitchFamily="49" charset="0"/>
+              </a:rPr>
+              <a:t>orientation</a:t>
+            </a:r>
+          </a:p>
+          <a:p>
+            <a:pPr lvl="1"/>
+            <a:r>
+              <a:rPr lang="en-US">
+                <a:solidFill>
+                  <a:schemeClr val="accent6">
+                    <a:lumMod val="50000"/>
+                  </a:schemeClr>
+                </a:solidFill>
+                <a:latin typeface="Consolas" panose="020B0609020204030204" pitchFamily="49" charset="0"/>
+              </a:rPr>
+              <a:t>resolution</a:t>
+            </a:r>
+          </a:p>
+          <a:p>
+            <a:pPr lvl="1"/>
+            <a:r>
+              <a:rPr lang="fr-BE">
+                <a:solidFill>
+                  <a:srgbClr val="996633"/>
+                </a:solidFill>
+                <a:latin typeface="Consolas" panose="020B0609020204030204" pitchFamily="49" charset="0"/>
+              </a:rPr>
+              <a:t>prefers-color-scheme</a:t>
+            </a:r>
+          </a:p>
+        </p:txBody>
+      </p:sp>
+      <p:sp>
+        <p:nvSpPr>
+          <p:cNvPr id="4" name="Espace réservé du numéro de diapositive 3">
+            <a:extLst>
+              <a:ext uri="{FF2B5EF4-FFF2-40B4-BE49-F238E27FC236}">
+                <a16:creationId xmlns:a16="http://schemas.microsoft.com/office/drawing/2014/main" id="{5A712CBD-7C34-21B5-C8AD-A9D24B8B9127}"/>
+              </a:ext>
+            </a:extLst>
+          </p:cNvPr>
+          <p:cNvSpPr>
+            <a:spLocks noGrp="1"/>
+          </p:cNvSpPr>
+          <p:nvPr>
+            <p:ph type="sldNum" sz="quarter" idx="12"/>
+          </p:nvPr>
+        </p:nvSpPr>
+        <p:spPr/>
+        <p:txBody>
+          <a:bodyPr/>
+          <a:lstStyle/>
+          <a:p>
+            <a:fld id="{02C092ED-0E97-497E-99D9-BB9DD7276F53}" type="slidenum">
+              <a:rPr lang="fr-BE" smtClean="0"/>
+              <a:t>55</a:t>
+            </a:fld>
+            <a:endParaRPr lang="fr-BE"/>
+          </a:p>
+        </p:txBody>
+      </p:sp>
+      <p:sp>
+        <p:nvSpPr>
+          <p:cNvPr id="7" name="ZoneTexte 6">
+            <a:extLst>
+              <a:ext uri="{FF2B5EF4-FFF2-40B4-BE49-F238E27FC236}">
+                <a16:creationId xmlns:a16="http://schemas.microsoft.com/office/drawing/2014/main" id="{20F79AA4-1254-565B-DECF-021A5286784D}"/>
+              </a:ext>
+            </a:extLst>
+          </p:cNvPr>
+          <p:cNvSpPr txBox="1"/>
+          <p:nvPr/>
+        </p:nvSpPr>
+        <p:spPr>
+          <a:xfrm>
+            <a:off x="2275172" y="1320399"/>
+            <a:ext cx="7641657" cy="2308324"/>
+          </a:xfrm>
+          <a:prstGeom prst="rect">
+            <a:avLst/>
+          </a:prstGeom>
+          <a:noFill/>
+        </p:spPr>
+        <p:txBody>
+          <a:bodyPr wrap="square" rtlCol="0">
+            <a:spAutoFit/>
+          </a:bodyPr>
+          <a:lstStyle/>
+          <a:p>
+            <a:r>
+              <a:rPr lang="en-US">
+                <a:solidFill>
+                  <a:schemeClr val="accent2"/>
+                </a:solidFill>
+                <a:latin typeface="Consolas" panose="020B0609020204030204" pitchFamily="49" charset="0"/>
+              </a:rPr>
+              <a:t>@media </a:t>
+            </a:r>
+            <a:r>
+              <a:rPr lang="en-US">
+                <a:latin typeface="Consolas" panose="020B0609020204030204" pitchFamily="49" charset="0"/>
+              </a:rPr>
+              <a:t>not|only </a:t>
+            </a:r>
+            <a:r>
+              <a:rPr lang="en-US">
+                <a:solidFill>
+                  <a:schemeClr val="accent6">
+                    <a:lumMod val="50000"/>
+                  </a:schemeClr>
+                </a:solidFill>
+                <a:latin typeface="Consolas" panose="020B0609020204030204" pitchFamily="49" charset="0"/>
+              </a:rPr>
+              <a:t>mediatype</a:t>
+            </a:r>
+            <a:r>
+              <a:rPr lang="en-US">
+                <a:solidFill>
+                  <a:schemeClr val="accent2"/>
+                </a:solidFill>
+                <a:latin typeface="Consolas" panose="020B0609020204030204" pitchFamily="49" charset="0"/>
+              </a:rPr>
+              <a:t> </a:t>
+            </a:r>
+            <a:r>
+              <a:rPr lang="en-US">
+                <a:latin typeface="Consolas" panose="020B0609020204030204" pitchFamily="49" charset="0"/>
+              </a:rPr>
+              <a:t>and</a:t>
+            </a:r>
+            <a:r>
+              <a:rPr lang="en-US">
+                <a:solidFill>
+                  <a:schemeClr val="accent2"/>
+                </a:solidFill>
+                <a:latin typeface="Consolas" panose="020B0609020204030204" pitchFamily="49" charset="0"/>
+              </a:rPr>
+              <a:t>  	</a:t>
+            </a:r>
+            <a:br>
+              <a:rPr lang="en-US">
+                <a:solidFill>
+                  <a:schemeClr val="accent2"/>
+                </a:solidFill>
+                <a:latin typeface="Consolas" panose="020B0609020204030204" pitchFamily="49" charset="0"/>
+              </a:rPr>
+            </a:br>
+            <a:r>
+              <a:rPr lang="en-US">
+                <a:solidFill>
+                  <a:schemeClr val="accent2"/>
+                </a:solidFill>
+                <a:latin typeface="Consolas" panose="020B0609020204030204" pitchFamily="49" charset="0"/>
+              </a:rPr>
+              <a:t>( </a:t>
+            </a:r>
+            <a:r>
+              <a:rPr lang="en-US">
+                <a:solidFill>
+                  <a:schemeClr val="accent6">
+                    <a:lumMod val="50000"/>
+                  </a:schemeClr>
+                </a:solidFill>
+                <a:latin typeface="Consolas" panose="020B0609020204030204" pitchFamily="49" charset="0"/>
+              </a:rPr>
+              <a:t>mediafeature</a:t>
+            </a:r>
+            <a:r>
+              <a:rPr lang="en-US">
+                <a:solidFill>
+                  <a:schemeClr val="accent2"/>
+                </a:solidFill>
+                <a:latin typeface="Consolas" panose="020B0609020204030204" pitchFamily="49" charset="0"/>
+              </a:rPr>
+              <a:t> </a:t>
+            </a:r>
+            <a:r>
+              <a:rPr lang="en-US">
+                <a:latin typeface="Consolas" panose="020B0609020204030204" pitchFamily="49" charset="0"/>
+              </a:rPr>
+              <a:t>and|or|not </a:t>
+            </a:r>
+            <a:r>
+              <a:rPr lang="en-US">
+                <a:solidFill>
+                  <a:schemeClr val="accent6">
+                    <a:lumMod val="50000"/>
+                  </a:schemeClr>
+                </a:solidFill>
+                <a:latin typeface="Consolas" panose="020B0609020204030204" pitchFamily="49" charset="0"/>
+              </a:rPr>
+              <a:t>mediafeature </a:t>
+            </a:r>
+            <a:r>
+              <a:rPr lang="en-US">
+                <a:solidFill>
+                  <a:schemeClr val="accent2"/>
+                </a:solidFill>
+                <a:latin typeface="Consolas" panose="020B0609020204030204" pitchFamily="49" charset="0"/>
+              </a:rPr>
+              <a:t>) </a:t>
+            </a:r>
+            <a:br>
+              <a:rPr lang="en-US">
+                <a:solidFill>
+                  <a:schemeClr val="accent2"/>
+                </a:solidFill>
+                <a:latin typeface="Consolas" panose="020B0609020204030204" pitchFamily="49" charset="0"/>
+              </a:rPr>
+            </a:br>
+            <a:r>
+              <a:rPr lang="en-US">
+                <a:latin typeface="Consolas" panose="020B0609020204030204" pitchFamily="49" charset="0"/>
+              </a:rPr>
+              <a:t>{ </a:t>
+            </a:r>
+            <a:br>
+              <a:rPr lang="en-US">
+                <a:solidFill>
+                  <a:schemeClr val="accent2"/>
+                </a:solidFill>
+                <a:latin typeface="Consolas" panose="020B0609020204030204" pitchFamily="49" charset="0"/>
+              </a:rPr>
+            </a:br>
+            <a:r>
+              <a:rPr lang="en-US">
+                <a:solidFill>
+                  <a:schemeClr val="accent2"/>
+                </a:solidFill>
+                <a:latin typeface="Consolas" panose="020B0609020204030204" pitchFamily="49" charset="0"/>
+              </a:rPr>
+              <a:t>	</a:t>
+            </a:r>
+            <a:r>
+              <a:rPr lang="en-US">
+                <a:solidFill>
+                  <a:schemeClr val="accent5"/>
+                </a:solidFill>
+                <a:latin typeface="Consolas" panose="020B0609020204030204" pitchFamily="49" charset="0"/>
+              </a:rPr>
+              <a:t>CSS-Code; </a:t>
+            </a:r>
+            <a:br>
+              <a:rPr lang="en-US">
+                <a:solidFill>
+                  <a:schemeClr val="accent2"/>
+                </a:solidFill>
+                <a:latin typeface="Consolas" panose="020B0609020204030204" pitchFamily="49" charset="0"/>
+              </a:rPr>
+            </a:br>
+            <a:r>
+              <a:rPr lang="en-US">
+                <a:latin typeface="Consolas" panose="020B0609020204030204" pitchFamily="49" charset="0"/>
+              </a:rPr>
+              <a:t>}</a:t>
+            </a:r>
+          </a:p>
+          <a:p>
+            <a:endParaRPr lang="fr-BE"/>
+          </a:p>
+        </p:txBody>
+      </p:sp>
+    </p:spTree>
+    <p:extLst>
+      <p:ext uri="{BB962C8B-B14F-4D97-AF65-F5344CB8AC3E}">
+        <p14:creationId xmlns:p14="http://schemas.microsoft.com/office/powerpoint/2010/main" val="625327841"/>
+      </p:ext>
+    </p:extLst>
+  </p:cSld>
+  <p:clrMapOvr>
+    <a:masterClrMapping/>
+  </p:clrMapOvr>
+  <mc:AlternateContent xmlns:mc="http://schemas.openxmlformats.org/markup-compatibility/2006">
+    <mc:Choice xmlns:p14="http://schemas.microsoft.com/office/powerpoint/2010/main" Requires="p14">
+      <p:transition spd="slow">
+        <p14:reveal/>
+      </p:transition>
+    </mc:Choice>
+    <mc:Fallback>
+      <p:transition spd="slow">
+        <p:fade/>
+      </p:transition>
+    </mc:Fallback>
+  </mc:AlternateContent>
+</p:sld>
+</file>
+
+<file path=ppt/slides/slide56.xml><?xml version="1.0" encoding="utf-8"?>
+<p:sld xmlns:a="http://schemas.openxmlformats.org/drawingml/2006/main" xmlns:r="http://schemas.openxmlformats.org/officeDocument/2006/relationships" xmlns:p="http://schemas.openxmlformats.org/presentationml/2006/main">
+  <p:cSld>
+    <p:spTree>
+      <p:nvGrpSpPr>
+        <p:cNvPr id="1" name="">
+          <a:extLst>
+            <a:ext uri="{FF2B5EF4-FFF2-40B4-BE49-F238E27FC236}">
               <a16:creationId xmlns:a16="http://schemas.microsoft.com/office/drawing/2014/main" id="{E86E7EAF-6500-CE4F-B716-DED3C69E0F0E}"/>
             </a:ext>
           </a:extLst>
@@ -32807,7 +33214,7 @@
           <a:p>
             <a:fld id="{02C092ED-0E97-497E-99D9-BB9DD7276F53}" type="slidenum">
               <a:rPr lang="fr-BE" smtClean="0"/>
-              <a:t>55</a:t>
+              <a:t>56</a:t>
             </a:fld>
             <a:endParaRPr lang="fr-BE"/>
           </a:p>
@@ -32874,7 +33281,7 @@
 </p:sld>
 </file>
 
-<file path=ppt/slides/slide56.xml><?xml version="1.0" encoding="utf-8"?>
+<file path=ppt/slides/slide57.xml><?xml version="1.0" encoding="utf-8"?>
 <p:sld xmlns:a="http://schemas.openxmlformats.org/drawingml/2006/main" xmlns:r="http://schemas.openxmlformats.org/officeDocument/2006/relationships" xmlns:p="http://schemas.openxmlformats.org/presentationml/2006/main">
   <p:cSld>
     <p:spTree>
@@ -33448,271 +33855,7 @@
         <p14:reveal/>
       </p:transition>
     </mc:Choice>
-    <mc:Fallback xmlns="" xmlns:mv="urn:schemas-microsoft-com:mac:vml" xmlns:c="http://schemas.openxmlformats.org/drawingml/2006/chart" xmlns:dgm="http://schemas.openxmlformats.org/drawingml/2006/diagram" xmlns:o="urn:schemas-microsoft-com:office:office" xmlns:v="urn:schemas-microsoft-com:vml" xmlns:pvml="urn:schemas-microsoft-com:office:powerpoint" xmlns:com="http://schemas.openxmlformats.org/drawingml/2006/compatibility" xmlns:p15="http://schemas.microsoft.com/office/powerpoint/2012/main" xmlns:ahyp="http://schemas.microsoft.com/office/drawing/2018/hyperlinkcolor">
-      <p:transition spd="med">
-        <p:fade/>
-      </p:transition>
-    </mc:Fallback>
-  </mc:AlternateContent>
-</p:sld>
-</file>
-
-<file path=ppt/slides/slide57.xml><?xml version="1.0" encoding="utf-8"?>
-<p:sld xmlns:a="http://schemas.openxmlformats.org/drawingml/2006/main" xmlns:r="http://schemas.openxmlformats.org/officeDocument/2006/relationships" xmlns:p="http://schemas.openxmlformats.org/presentationml/2006/main">
-  <p:cSld>
-    <p:spTree>
-      <p:nvGrpSpPr>
-        <p:cNvPr id="1" name="Shape 1111"/>
-        <p:cNvGrpSpPr/>
-        <p:nvPr/>
-      </p:nvGrpSpPr>
-      <p:grpSpPr>
-        <a:xfrm>
-          <a:off x="0" y="0"/>
-          <a:ext cx="0" cy="0"/>
-          <a:chOff x="0" y="0"/>
-          <a:chExt cx="0" cy="0"/>
-        </a:xfrm>
-      </p:grpSpPr>
-      <p:sp>
-        <p:nvSpPr>
-          <p:cNvPr id="1112" name="Google Shape;1112;p135"/>
-          <p:cNvSpPr txBox="1">
-            <a:spLocks noGrp="1"/>
-          </p:cNvSpPr>
-          <p:nvPr>
-            <p:ph type="title"/>
-          </p:nvPr>
-        </p:nvSpPr>
-        <p:spPr>
-          <a:prstGeom prst="rect">
-            <a:avLst/>
-          </a:prstGeom>
-          <a:noFill/>
-          <a:ln>
-            <a:noFill/>
-          </a:ln>
-        </p:spPr>
-        <p:txBody>
-          <a:bodyPr spcFirstLastPara="1" wrap="square" lIns="91425" tIns="45700" rIns="91425" bIns="45700" anchor="ctr" anchorCtr="0">
-            <a:normAutofit/>
-          </a:bodyPr>
-          <a:lstStyle/>
-          <a:p>
-            <a:pPr marL="0" lvl="0" indent="0" algn="l" rtl="0">
-              <a:lnSpc>
-                <a:spcPct val="90000"/>
-              </a:lnSpc>
-              <a:spcBef>
-                <a:spcPts val="0"/>
-              </a:spcBef>
-              <a:spcAft>
-                <a:spcPts val="0"/>
-              </a:spcAft>
-              <a:buClr>
-                <a:schemeClr val="accent5"/>
-              </a:buClr>
-              <a:buSzPts val="4400"/>
-              <a:buFont typeface="Garamond"/>
-              <a:buNone/>
-            </a:pPr>
-            <a:r>
-              <a:rPr lang="fr-BE"/>
-              <a:t>Exemples</a:t>
-            </a:r>
-            <a:endParaRPr/>
-          </a:p>
-        </p:txBody>
-      </p:sp>
-      <p:sp>
-        <p:nvSpPr>
-          <p:cNvPr id="1113" name="Google Shape;1113;p135"/>
-          <p:cNvSpPr txBox="1">
-            <a:spLocks noGrp="1"/>
-          </p:cNvSpPr>
-          <p:nvPr>
-            <p:ph sz="half" idx="1"/>
-          </p:nvPr>
-        </p:nvSpPr>
-        <p:spPr>
-          <a:xfrm>
-            <a:off x="838199" y="1825625"/>
-            <a:ext cx="6221627" cy="4351339"/>
-          </a:xfrm>
-          <a:prstGeom prst="rect">
-            <a:avLst/>
-          </a:prstGeom>
-          <a:noFill/>
-          <a:ln>
-            <a:noFill/>
-          </a:ln>
-        </p:spPr>
-        <p:txBody>
-          <a:bodyPr spcFirstLastPara="1" wrap="square" lIns="91425" tIns="45700" rIns="91425" bIns="45700" anchor="t" anchorCtr="0">
-            <a:normAutofit/>
-          </a:bodyPr>
-          <a:lstStyle/>
-          <a:p>
-            <a:pPr>
-              <a:spcBef>
-                <a:spcPts val="0"/>
-              </a:spcBef>
-              <a:buClr>
-                <a:schemeClr val="dk1"/>
-              </a:buClr>
-              <a:buSzPts val="3600"/>
-            </a:pPr>
-            <a:r>
-              <a:rPr lang="fr-BE"/>
-              <a:t>VOO </a:t>
-            </a:r>
-            <a:endParaRPr/>
-          </a:p>
-          <a:p>
-            <a:pPr>
-              <a:buClr>
-                <a:schemeClr val="dk1"/>
-              </a:buClr>
-              <a:buSzPts val="3600"/>
-            </a:pPr>
-            <a:r>
-              <a:rPr lang="fr-BE"/>
-              <a:t>Desigual</a:t>
-            </a:r>
-            <a:endParaRPr/>
-          </a:p>
-          <a:p>
-            <a:pPr>
-              <a:buClr>
-                <a:schemeClr val="dk1"/>
-              </a:buClr>
-              <a:buSzPts val="3600"/>
-            </a:pPr>
-            <a:r>
-              <a:rPr lang="fr-BE"/>
-              <a:t>Edwin</a:t>
-            </a:r>
-            <a:endParaRPr/>
-          </a:p>
-          <a:p>
-            <a:pPr marL="800094" indent="-571500">
-              <a:buClr>
-                <a:schemeClr val="dk1"/>
-              </a:buClr>
-              <a:buSzPts val="3600"/>
-            </a:pPr>
-            <a:endParaRPr/>
-          </a:p>
-        </p:txBody>
-      </p:sp>
-      <p:pic>
-        <p:nvPicPr>
-          <p:cNvPr id="1114" name="Google Shape;1114;p135"/>
-          <p:cNvPicPr preferRelativeResize="0"/>
-          <p:nvPr/>
-        </p:nvPicPr>
-        <p:blipFill rotWithShape="1">
-          <a:blip r:embed="rId3" cstate="email">
-            <a:alphaModFix/>
-            <a:extLst>
-              <a:ext uri="{28A0092B-C50C-407E-A947-70E740481C1C}">
-                <a14:useLocalDpi xmlns:a14="http://schemas.microsoft.com/office/drawing/2010/main"/>
-              </a:ext>
-            </a:extLst>
-          </a:blip>
-          <a:srcRect/>
-          <a:stretch/>
-        </p:blipFill>
-        <p:spPr>
-          <a:xfrm>
-            <a:off x="6372354" y="681036"/>
-            <a:ext cx="3823589" cy="2376293"/>
-          </a:xfrm>
-          <a:prstGeom prst="rect">
-            <a:avLst/>
-          </a:prstGeom>
-          <a:noFill/>
-          <a:ln>
-            <a:noFill/>
-          </a:ln>
-        </p:spPr>
-      </p:pic>
-      <p:pic>
-        <p:nvPicPr>
-          <p:cNvPr id="1115" name="Google Shape;1115;p135"/>
-          <p:cNvPicPr preferRelativeResize="0"/>
-          <p:nvPr/>
-        </p:nvPicPr>
-        <p:blipFill rotWithShape="1">
-          <a:blip r:embed="rId4" cstate="email">
-            <a:alphaModFix/>
-            <a:extLst>
-              <a:ext uri="{28A0092B-C50C-407E-A947-70E740481C1C}">
-                <a14:useLocalDpi xmlns:a14="http://schemas.microsoft.com/office/drawing/2010/main"/>
-              </a:ext>
-            </a:extLst>
-          </a:blip>
-          <a:srcRect/>
-          <a:stretch/>
-        </p:blipFill>
-        <p:spPr>
-          <a:xfrm>
-            <a:off x="6372354" y="3748717"/>
-            <a:ext cx="3823589" cy="2713616"/>
-          </a:xfrm>
-          <a:prstGeom prst="rect">
-            <a:avLst/>
-          </a:prstGeom>
-          <a:noFill/>
-          <a:ln>
-            <a:noFill/>
-          </a:ln>
-        </p:spPr>
-      </p:pic>
-      <p:pic>
-        <p:nvPicPr>
-          <p:cNvPr id="1116" name="Google Shape;1116;p135"/>
-          <p:cNvPicPr preferRelativeResize="0"/>
-          <p:nvPr/>
-        </p:nvPicPr>
-        <p:blipFill rotWithShape="1">
-          <a:blip r:embed="rId5" cstate="email">
-            <a:alphaModFix/>
-            <a:extLst>
-              <a:ext uri="{28A0092B-C50C-407E-A947-70E740481C1C}">
-                <a14:useLocalDpi xmlns:a14="http://schemas.microsoft.com/office/drawing/2010/main"/>
-              </a:ext>
-            </a:extLst>
-          </a:blip>
-          <a:srcRect/>
-          <a:stretch/>
-        </p:blipFill>
-        <p:spPr>
-          <a:xfrm>
-            <a:off x="672190" y="3753853"/>
-            <a:ext cx="4842949" cy="2708480"/>
-          </a:xfrm>
-          <a:prstGeom prst="rect">
-            <a:avLst/>
-          </a:prstGeom>
-          <a:noFill/>
-          <a:ln>
-            <a:noFill/>
-          </a:ln>
-        </p:spPr>
-      </p:pic>
-    </p:spTree>
-  </p:cSld>
-  <p:clrMapOvr>
-    <a:masterClrMapping/>
-  </p:clrMapOvr>
-  <mc:AlternateContent xmlns:mc="http://schemas.openxmlformats.org/markup-compatibility/2006" xmlns:p14="http://schemas.microsoft.com/office/powerpoint/2010/main">
-    <mc:Choice Requires="p14">
-      <p:transition spd="slow">
-        <p14:reveal/>
-      </p:transition>
-    </mc:Choice>
-    <mc:Fallback xmlns="" xmlns:mv="urn:schemas-microsoft-com:mac:vml" xmlns:c="http://schemas.openxmlformats.org/drawingml/2006/chart" xmlns:dgm="http://schemas.openxmlformats.org/drawingml/2006/diagram" xmlns:o="urn:schemas-microsoft-com:office:office" xmlns:v="urn:schemas-microsoft-com:vml" xmlns:pvml="urn:schemas-microsoft-com:office:powerpoint" xmlns:com="http://schemas.openxmlformats.org/drawingml/2006/compatibility" xmlns:p15="http://schemas.microsoft.com/office/powerpoint/2012/main" xmlns:ahyp="http://schemas.microsoft.com/office/drawing/2018/hyperlinkcolor">
+    <mc:Fallback xmlns:ahyp="http://schemas.microsoft.com/office/drawing/2018/hyperlinkcolor" xmlns:p15="http://schemas.microsoft.com/office/powerpoint/2012/main" xmlns:com="http://schemas.openxmlformats.org/drawingml/2006/compatibility" xmlns:pvml="urn:schemas-microsoft-com:office:powerpoint" xmlns:v="urn:schemas-microsoft-com:vml" xmlns:o="urn:schemas-microsoft-com:office:office" xmlns:dgm="http://schemas.openxmlformats.org/drawingml/2006/diagram" xmlns:c="http://schemas.openxmlformats.org/drawingml/2006/chart" xmlns:mv="urn:schemas-microsoft-com:mac:vml" xmlns="">
       <p:transition spd="med">
         <p:fade/>
       </p:transition>
@@ -33858,7 +34001,7 @@
         <p14:reveal/>
       </p:transition>
     </mc:Choice>
-    <mc:Fallback xmlns="" xmlns:mv="urn:schemas-microsoft-com:mac:vml" xmlns:c="http://schemas.openxmlformats.org/drawingml/2006/chart" xmlns:dgm="http://schemas.openxmlformats.org/drawingml/2006/diagram" xmlns:o="urn:schemas-microsoft-com:office:office" xmlns:v="urn:schemas-microsoft-com:vml" xmlns:pvml="urn:schemas-microsoft-com:office:powerpoint" xmlns:com="http://schemas.openxmlformats.org/drawingml/2006/compatibility" xmlns:p15="http://schemas.microsoft.com/office/powerpoint/2012/main" xmlns:ahyp="http://schemas.microsoft.com/office/drawing/2018/hyperlinkcolor">
+    <mc:Fallback xmlns:ahyp="http://schemas.microsoft.com/office/drawing/2018/hyperlinkcolor" xmlns:p15="http://schemas.microsoft.com/office/powerpoint/2012/main" xmlns:com="http://schemas.openxmlformats.org/drawingml/2006/compatibility" xmlns:pvml="urn:schemas-microsoft-com:office:powerpoint" xmlns:v="urn:schemas-microsoft-com:vml" xmlns:o="urn:schemas-microsoft-com:office:office" xmlns:dgm="http://schemas.openxmlformats.org/drawingml/2006/diagram" xmlns:c="http://schemas.openxmlformats.org/drawingml/2006/chart" xmlns:mv="urn:schemas-microsoft-com:mac:vml" xmlns="">
       <p:transition spd="med">
         <p:fade/>
       </p:transition>
@@ -34092,7 +34235,7 @@
         <p14:reveal/>
       </p:transition>
     </mc:Choice>
-    <mc:Fallback xmlns="" xmlns:mv="urn:schemas-microsoft-com:mac:vml" xmlns:c="http://schemas.openxmlformats.org/drawingml/2006/chart" xmlns:dgm="http://schemas.openxmlformats.org/drawingml/2006/diagram" xmlns:o="urn:schemas-microsoft-com:office:office" xmlns:v="urn:schemas-microsoft-com:vml" xmlns:pvml="urn:schemas-microsoft-com:office:powerpoint" xmlns:com="http://schemas.openxmlformats.org/drawingml/2006/compatibility" xmlns:p15="http://schemas.microsoft.com/office/powerpoint/2012/main" xmlns:ahyp="http://schemas.microsoft.com/office/drawing/2018/hyperlinkcolor">
+    <mc:Fallback xmlns:ahyp="http://schemas.microsoft.com/office/drawing/2018/hyperlinkcolor" xmlns:p15="http://schemas.microsoft.com/office/powerpoint/2012/main" xmlns:com="http://schemas.openxmlformats.org/drawingml/2006/compatibility" xmlns:pvml="urn:schemas-microsoft-com:office:powerpoint" xmlns:v="urn:schemas-microsoft-com:vml" xmlns:o="urn:schemas-microsoft-com:office:office" xmlns:dgm="http://schemas.openxmlformats.org/drawingml/2006/diagram" xmlns:c="http://schemas.openxmlformats.org/drawingml/2006/chart" xmlns:mv="urn:schemas-microsoft-com:mac:vml" xmlns="">
       <p:transition spd="med">
         <p:fade/>
       </p:transition>
@@ -34577,7 +34720,7 @@
         <p14:reveal/>
       </p:transition>
     </mc:Choice>
-    <mc:Fallback xmlns="" xmlns:mv="urn:schemas-microsoft-com:mac:vml" xmlns:c="http://schemas.openxmlformats.org/drawingml/2006/chart" xmlns:dgm="http://schemas.openxmlformats.org/drawingml/2006/diagram" xmlns:o="urn:schemas-microsoft-com:office:office" xmlns:v="urn:schemas-microsoft-com:vml" xmlns:pvml="urn:schemas-microsoft-com:office:powerpoint" xmlns:com="http://schemas.openxmlformats.org/drawingml/2006/compatibility" xmlns:p15="http://schemas.microsoft.com/office/powerpoint/2012/main" xmlns:ahyp="http://schemas.microsoft.com/office/drawing/2018/hyperlinkcolor">
+    <mc:Fallback xmlns:ahyp="http://schemas.microsoft.com/office/drawing/2018/hyperlinkcolor" xmlns:p15="http://schemas.microsoft.com/office/powerpoint/2012/main" xmlns:com="http://schemas.openxmlformats.org/drawingml/2006/compatibility" xmlns:pvml="urn:schemas-microsoft-com:office:powerpoint" xmlns:v="urn:schemas-microsoft-com:vml" xmlns:o="urn:schemas-microsoft-com:office:office" xmlns:dgm="http://schemas.openxmlformats.org/drawingml/2006/diagram" xmlns:c="http://schemas.openxmlformats.org/drawingml/2006/chart" xmlns:mv="urn:schemas-microsoft-com:mac:vml" xmlns="">
       <p:transition spd="med">
         <p:fade/>
       </p:transition>
@@ -35190,7 +35333,7 @@
         <p14:reveal/>
       </p:transition>
     </mc:Choice>
-    <mc:Fallback xmlns="" xmlns:mv="urn:schemas-microsoft-com:mac:vml" xmlns:c="http://schemas.openxmlformats.org/drawingml/2006/chart" xmlns:dgm="http://schemas.openxmlformats.org/drawingml/2006/diagram" xmlns:o="urn:schemas-microsoft-com:office:office" xmlns:v="urn:schemas-microsoft-com:vml" xmlns:pvml="urn:schemas-microsoft-com:office:powerpoint" xmlns:com="http://schemas.openxmlformats.org/drawingml/2006/compatibility" xmlns:p15="http://schemas.microsoft.com/office/powerpoint/2012/main" xmlns:ahyp="http://schemas.microsoft.com/office/drawing/2018/hyperlinkcolor">
+    <mc:Fallback xmlns:ahyp="http://schemas.microsoft.com/office/drawing/2018/hyperlinkcolor" xmlns:p15="http://schemas.microsoft.com/office/powerpoint/2012/main" xmlns:com="http://schemas.openxmlformats.org/drawingml/2006/compatibility" xmlns:pvml="urn:schemas-microsoft-com:office:powerpoint" xmlns:v="urn:schemas-microsoft-com:vml" xmlns:o="urn:schemas-microsoft-com:office:office" xmlns:dgm="http://schemas.openxmlformats.org/drawingml/2006/diagram" xmlns:c="http://schemas.openxmlformats.org/drawingml/2006/chart" xmlns:mv="urn:schemas-microsoft-com:mac:vml" xmlns="">
       <p:transition spd="med">
         <p:fade/>
       </p:transition>

</xml_diff>